<commit_message>
Apply Severny Proekt branding and logo; tailor deck to tanker seasons; add data request
Co-Authored-By: Claude Sonnet 5.5 <noreply@anthropic.com>
Claude-Session: https://claude.ai/code/session_01NknPrkgT7ASbMFec99CZjD
</commit_message>
<xml_diff>
--- a/Arktika_dengi_i_bezopasnost.pptx
+++ b/Arktika_dengi_i_bezopasnost.pptx
@@ -119,38 +119,38 @@
   <p:extLst>
     <p:ext uri="{521415D9-36F7-43E2-AB2F-B90AF26B5E84}">
       <p14:sectionLst xmlns:p14="http://schemas.microsoft.com/office/powerpoint/2010/main">
-        <p14:section name="Вступление" id="{326af37e-68b8-d450-dcbd-b19a2b6a024a}">
+        <p14:section name="Вступление" id="{8b1f9ba4-15e8-dda8-3a84-9dbb819e4926}">
           <p14:sldIdLst>
             <p14:sldId id="256"/>
             <p14:sldId id="257"/>
           </p14:sldIdLst>
         </p14:section>
-        <p14:section name="Картина" id="{b5071dad-a00f-e29a-f5b8-d2f1d3f4f58b}">
+        <p14:section name="Картина" id="{f56cff68-2892-a24a-567d-0236e7eae5f4}">
           <p14:sldIdLst>
             <p14:sldId id="258"/>
             <p14:sldId id="259"/>
           </p14:sldIdLst>
         </p14:section>
-        <p14:section name="Деньги" id="{e3d75881-d9ad-875d-3d10-c72882ad656b}">
+        <p14:section name="Деньги" id="{a61560a9-ccb3-84a3-6899-f8df54b599a0}">
           <p14:sldIdLst>
             <p14:sldId id="260"/>
             <p14:sldId id="261"/>
             <p14:sldId id="262"/>
           </p14:sldIdLst>
         </p14:section>
-        <p14:section name="Безопасность" id="{b8eff3ef-b3b6-02f6-f1e4-b052381d42ad}">
+        <p14:section name="Безопасность" id="{bb20e653-5674-f3ac-dda6-68693af75441}">
           <p14:sldIdLst>
             <p14:sldId id="263"/>
             <p14:sldId id="264"/>
           </p14:sldIdLst>
         </p14:section>
-        <p14:section name="Риски" id="{73241ab8-56cd-831a-f35c-1b58d283b616}">
+        <p14:section name="Риски" id="{eb899570-844d-fbea-5fb4-527a80323eb5}">
           <p14:sldIdLst>
             <p14:sldId id="265"/>
             <p14:sldId id="266"/>
           </p14:sldIdLst>
         </p14:section>
-        <p14:section name="Итоги" id="{4f4edef3-eb5d-aa2c-0076-e4d43cd9dffb}">
+        <p14:section name="Итоги" id="{9f1b21b6-4786-efea-a3cb-5f94434f70e4}">
           <p14:sldIdLst>
             <p14:sldId id="267"/>
             <p14:sldId id="268"/>
@@ -179,7 +179,7 @@
             <a:pPr>
               <a:defRPr sz="1200" b="0" i="0" u="none" strike="noStrike">
                 <a:solidFill>
-                  <a:srgbClr val="0B1F33"/>
+                  <a:srgbClr val="1E1640"/>
                 </a:solidFill>
                 <a:latin typeface="+mn-lt"/>
               </a:defRPr>
@@ -187,7 +187,7 @@
             <a:r>
               <a:rPr sz="1200" b="0" i="0" u="none" strike="noStrike">
                 <a:solidFill>
-                  <a:srgbClr val="0B1F33"/>
+                  <a:srgbClr val="1E1640"/>
                 </a:solidFill>
                 <a:latin typeface="+mn-lt"/>
               </a:rPr>
@@ -222,7 +222,7 @@
           </c:tx>
           <c:spPr>
             <a:solidFill>
-              <a:srgbClr val="1B9AAA"/>
+              <a:srgbClr val="3E8E34"/>
             </a:solidFill>
             <a:effectLst/>
           </c:spPr>
@@ -236,7 +236,7 @@
                 <a:pPr>
                   <a:defRPr b="1" i="0" strike="noStrike" sz="1200" u="none">
                     <a:solidFill>
-                      <a:srgbClr val="0B1F33"/>
+                      <a:srgbClr val="1E1640"/>
                     </a:solidFill>
                     <a:latin typeface="+mn-lt"/>
                   </a:defRPr>
@@ -304,7 +304,7 @@
               <a:pPr>
                 <a:defRPr b="1" i="0" strike="noStrike" sz="1200" u="none">
                   <a:solidFill>
-                    <a:srgbClr val="0B1F33"/>
+                    <a:srgbClr val="1E1640"/>
                   </a:solidFill>
                   <a:latin typeface="+mn-lt"/>
                 </a:defRPr>
@@ -352,7 +352,7 @@
             <a:pPr>
               <a:defRPr sz="1100" b="0" i="0" u="none" strike="noStrike">
                 <a:solidFill>
-                  <a:srgbClr val="0B1F33"/>
+                  <a:srgbClr val="1E1640"/>
                 </a:solidFill>
                 <a:latin typeface="+mn-lt"/>
               </a:defRPr>
@@ -406,7 +406,7 @@
             <a:pPr>
               <a:defRPr sz="1000" b="0" i="0" u="none" strike="noStrike">
                 <a:solidFill>
-                  <a:srgbClr val="3E6E8E"/>
+                  <a:srgbClr val="6B5CA5"/>
                 </a:solidFill>
                 <a:latin typeface="+mn-lt"/>
               </a:defRPr>
@@ -457,7 +457,7 @@
             <a:pPr>
               <a:defRPr sz="1200" b="0" i="0" u="none" strike="noStrike">
                 <a:solidFill>
-                  <a:srgbClr val="0B1F33"/>
+                  <a:srgbClr val="1E1640"/>
                 </a:solidFill>
                 <a:latin typeface="+mn-lt"/>
               </a:defRPr>
@@ -465,7 +465,7 @@
             <a:r>
               <a:rPr sz="1200" b="0" i="0" u="none" strike="noStrike">
                 <a:solidFill>
-                  <a:srgbClr val="0B1F33"/>
+                  <a:srgbClr val="1E1640"/>
                 </a:solidFill>
                 <a:latin typeface="+mn-lt"/>
               </a:rPr>
@@ -500,7 +500,7 @@
           </c:tx>
           <c:spPr>
             <a:solidFill>
-              <a:srgbClr val="3E6E8E"/>
+              <a:srgbClr val="6B5CA5"/>
             </a:solidFill>
             <a:effectLst/>
           </c:spPr>
@@ -514,7 +514,7 @@
                 <a:pPr>
                   <a:defRPr b="1" i="0" strike="noStrike" sz="1200" u="none">
                     <a:solidFill>
-                      <a:srgbClr val="0B1F33"/>
+                      <a:srgbClr val="1E1640"/>
                     </a:solidFill>
                     <a:latin typeface="+mn-lt"/>
                   </a:defRPr>
@@ -582,7 +582,7 @@
               <a:pPr>
                 <a:defRPr b="1" i="0" strike="noStrike" sz="1200" u="none">
                   <a:solidFill>
-                    <a:srgbClr val="0B1F33"/>
+                    <a:srgbClr val="1E1640"/>
                   </a:solidFill>
                   <a:latin typeface="+mn-lt"/>
                 </a:defRPr>
@@ -630,7 +630,7 @@
             <a:pPr>
               <a:defRPr sz="1100" b="0" i="0" u="none" strike="noStrike">
                 <a:solidFill>
-                  <a:srgbClr val="0B1F33"/>
+                  <a:srgbClr val="1E1640"/>
                 </a:solidFill>
                 <a:latin typeface="+mn-lt"/>
               </a:defRPr>
@@ -684,7 +684,7 @@
             <a:pPr>
               <a:defRPr sz="1000" b="0" i="0" u="none" strike="noStrike">
                 <a:solidFill>
-                  <a:srgbClr val="3E6E8E"/>
+                  <a:srgbClr val="6B5CA5"/>
                 </a:solidFill>
                 <a:latin typeface="+mn-lt"/>
               </a:defRPr>
@@ -735,7 +735,7 @@
             <a:pPr>
               <a:defRPr sz="1200" b="0" i="0" u="none" strike="noStrike">
                 <a:solidFill>
-                  <a:srgbClr val="0B1F33"/>
+                  <a:srgbClr val="1E1640"/>
                 </a:solidFill>
                 <a:latin typeface="+mn-lt"/>
               </a:defRPr>
@@ -743,7 +743,7 @@
             <a:r>
               <a:rPr sz="1200" b="0" i="0" u="none" strike="noStrike">
                 <a:solidFill>
-                  <a:srgbClr val="0B1F33"/>
+                  <a:srgbClr val="1E1640"/>
                 </a:solidFill>
                 <a:latin typeface="+mn-lt"/>
               </a:rPr>
@@ -778,7 +778,7 @@
           </c:tx>
           <c:spPr>
             <a:solidFill>
-              <a:srgbClr val="1B9AAA"/>
+              <a:srgbClr val="3E8E34"/>
             </a:solidFill>
             <a:effectLst/>
           </c:spPr>
@@ -792,7 +792,7 @@
                 <a:pPr>
                   <a:defRPr b="1" i="0" strike="noStrike" sz="1200" u="none">
                     <a:solidFill>
-                      <a:srgbClr val="0B1F33"/>
+                      <a:srgbClr val="1E1640"/>
                     </a:solidFill>
                     <a:latin typeface="+mn-lt"/>
                   </a:defRPr>
@@ -854,7 +854,7 @@
               <a:pPr>
                 <a:defRPr b="1" i="0" strike="noStrike" sz="1200" u="none">
                   <a:solidFill>
-                    <a:srgbClr val="0B1F33"/>
+                    <a:srgbClr val="1E1640"/>
                   </a:solidFill>
                   <a:latin typeface="+mn-lt"/>
                 </a:defRPr>
@@ -902,7 +902,7 @@
             <a:pPr>
               <a:defRPr sz="1100" b="0" i="0" u="none" strike="noStrike">
                 <a:solidFill>
-                  <a:srgbClr val="0B1F33"/>
+                  <a:srgbClr val="1E1640"/>
                 </a:solidFill>
                 <a:latin typeface="+mn-lt"/>
               </a:defRPr>
@@ -956,7 +956,7 @@
             <a:pPr>
               <a:defRPr sz="1000" b="0" i="0" u="none" strike="noStrike">
                 <a:solidFill>
-                  <a:srgbClr val="3E6E8E"/>
+                  <a:srgbClr val="6B5CA5"/>
                 </a:solidFill>
                 <a:latin typeface="+mn-lt"/>
               </a:defRPr>
@@ -1388,7 +1388,7 @@
           <a:p>
             <a:r>
               <a:rPr lang="en-US" dirty="0"/>
-              <a:t>[0:30] Добрый день. Тема — Арктика через призму двух вещей, которые в нашей профессии вечно спорят: деньги и безопасность. Формат: 15 минут рассказа, по ходу несколько вопросов к залу — отвечайте с места, мне важнее ваш опыт, чем мой слайд. Потом 15 минут обсуждения. Данные — на октябрь 2026, по официальным источникам: Росатом, Минтранс, Минвостокразвития, Правительство, плюс международные для сверки. Где источники расходятся — скажу прямо.</a:t>
+              <a:t>[0:30] Добрый день, коллеги. Тема — Арктика через призму двух вещей, которые в нашей профессии вечно спорят: деньги и безопасность. Формат: 15 минут рассказа, по ходу несколько вопросов к залу — отвечайте с места, мне важнее ваш опыт, чем мой слайд. Потом 15 минут обсуждения. Данные — на октябрь 2026, по официальным источникам: Росатом, Минтранс, Минвостокразвития, Правительство, плюс международные для сверки. Где источники расходятся — скажу прямо.</a:t>
             </a:r>
             <a:endParaRPr lang="en-US" dirty="0"/>
           </a:p>
@@ -2004,7 +2004,7 @@
           <a:p>
             <a:r>
               <a:rPr lang="en-US" dirty="0"/>
-              <a:t>[1:30] Возвращаемся к вопросу. Правильный ответ — Б: транзит Азия–Европа это 3,2 млн т из 37, то есть меньше 9%. Основа потока — вывоз с Ямала и Гыдана и северный завоз. Россия—Китай — ещё 5,4 млн т, около 15%. Контейнеры растут: 7, 14, 24 рейса, в 2026 планируют 30 и больше; с 15 августа 2026 первый в истории регулярный сервис Ningbo–Felixstowe с расписанием, около 21 дня в пути против 38–45 через Суэц. За сезон по данным китайской таможни — 8 рейсов и около 7,8 тыс. TEU; потом пауза до лета 2027. А вот для нас, сухогрузных, тревожный сигнал: сухие грузы в портах Арктического бассейна за 10 месяцев 2025 года упали на 16,4%. Спросите зал: кто из вас видит этот спад в своих рейсах?</a:t>
+              <a:t>[1:30] Возвращаемся к вопросу. Правильный ответ — Б: транзит Азия–Европа это 3,2 млн т из 37, то есть меньше 9%. Основа потока — вывоз с Ямала и Гыдана и северный завоз. Россия—Китай — ещё 5,4 млн т, около 15%. Контейнеры растут: 7, 14, 24 рейса, в 2026 планируют 30 и больше; с 15 августа 2026 первый в истории регулярный сервис Ningbo–Felixstowe с расписанием, около 21 дня в пути против 38–45 через Суэц. За сезон по данным китайской таможни — 8 рейсов и около 7,8 тыс. TEU; потом пауза до лета 2027. Наши танкеры работают как раз в основном сегменте потока: зимой вывоз конденсата, летом северный завоз. А вот для сухогрузов тревожный сигнал: сухие грузы в портах Арктического бассейна за 10 месяцев 2025 года упали на 16,4%. Спросите зал: кто из вас видит этот спад в своих рейсах?</a:t>
             </a:r>
             <a:endParaRPr lang="en-US" dirty="0"/>
           </a:p>
@@ -2268,7 +2268,7 @@
           <a:p>
             <a:r>
               <a:rPr lang="en-US" dirty="0"/>
-              <a:t>[1:45] Давайте считать как судовладельцы. Выигрыш СМП — время: около 21 дня против 38–45 через Суэц (оценки по контейнерному сервису Sea Legend, 2026). Но каждая позиция справа — деньги или риск. Формула внизу — не источник, а рабочая модель: умножьте экономию дней на стоимость судо-суток вашего судна и сравните с тарифом проводки, надбавками за ледовые условия и ожидаемым простоем. Для наших двух танкеров и сухогрузов цифры разные, но логика одна. Важно, что в зимнем плавании на восточном участке без проводки не обойтись — там лёд до трёх метров. Вопрос залу: какую долю суток вы бы заложили на ожидание ледокола в расчёт?</a:t>
+              <a:t>[1:45] Теперь про нас. Два танкера, два сезона. Лето — северный завоз: с 1 января 2026 года единый морской оператор — «Росатом Арктика», на 2026 год подтверждено более 264 тысяч тонн, на 65% больше, чем в 2025-м. Окно короткое, график зависит от льда. Зима — вывоз конденсата с Ямал СПГ и Арктик СПГ-2: здесь работает исключительное право российского флага, но главные расходы и риски — ледокольная проводка и ледовый класс. Арктик СПГ-2 под санкциями, отгрузки при этом растут: 3,6 млн т СПГ к 12 октября против 1,4 за весь 2025 год. Формула внизу — рабочая модель, не источник: считаем маржу сезона по каждому рейсу. Вопрос залу: какая часть зимней маржи уходит на проводку и ожидание ледокола?</a:t>
             </a:r>
             <a:endParaRPr lang="en-US" dirty="0"/>
           </a:p>
@@ -2551,7 +2551,7 @@
         <p:spPr>
           <a:xfrm>
             <a:off x="457200" y="274320"/>
-            <a:ext cx="8229600" cy="731520"/>
+            <a:ext cx="7132320" cy="731520"/>
           </a:xfrm>
           <a:prstGeom prst="rect">
             <a:avLst/>
@@ -2579,6 +2579,30 @@
           </a:p>
         </p:txBody>
       </p:sp>
+      <p:pic>
+        <p:nvPicPr>
+          <p:cNvPr id="3" name="Image 0" descr="/home/user/arctic_presentation_2026_10_20/logo.png">    </p:cNvPr>
+          <p:cNvPicPr>
+            <a:picLocks noChangeAspect="1"/>
+          </p:cNvPicPr>
+          <p:nvPr/>
+        </p:nvPicPr>
+        <p:blipFill>
+          <a:blip r:embed="rId1"/>
+          <a:stretch>
+            <a:fillRect/>
+          </a:stretch>
+        </p:blipFill>
+        <p:spPr>
+          <a:xfrm>
+            <a:off x="7772400" y="201168"/>
+            <a:ext cx="914400" cy="609905"/>
+          </a:xfrm>
+          <a:prstGeom prst="rect">
+            <a:avLst/>
+          </a:prstGeom>
+        </p:spPr>
+      </p:pic>
       <p:sp>
         <p:nvSpPr>
           <p:cNvPr id="25" name="Slide Number Placeholder 0"/>
@@ -2638,7 +2662,7 @@
     <p:bg>
       <p:bgPr>
         <a:solidFill>
-          <a:srgbClr val="0B1F33"/>
+          <a:srgbClr val="1E1640"/>
         </a:solidFill>
       </p:bgPr>
     </p:bg>
@@ -2667,7 +2691,7 @@
         <p:spPr>
           <a:xfrm>
             <a:off x="457200" y="274320"/>
-            <a:ext cx="8229600" cy="731520"/>
+            <a:ext cx="7132320" cy="731520"/>
           </a:xfrm>
           <a:prstGeom prst="rect">
             <a:avLst/>
@@ -2695,6 +2719,50 @@
           </a:p>
         </p:txBody>
       </p:sp>
+      <p:sp>
+        <p:nvSpPr>
+          <p:cNvPr id="3" name="Shape 0"/>
+          <p:cNvSpPr/>
+          <p:nvPr/>
+        </p:nvSpPr>
+        <p:spPr>
+          <a:xfrm>
+            <a:off x="7699248" y="155448"/>
+            <a:ext cx="1060704" cy="713232"/>
+          </a:xfrm>
+          <a:prstGeom prst="rect">
+            <a:avLst/>
+          </a:prstGeom>
+          <a:solidFill>
+            <a:srgbClr val="FFFFFF"/>
+          </a:solidFill>
+          <a:ln/>
+        </p:spPr>
+      </p:sp>
+      <p:pic>
+        <p:nvPicPr>
+          <p:cNvPr id="4" name="Image 0" descr="/home/user/arctic_presentation_2026_10_20/logo.png">    </p:cNvPr>
+          <p:cNvPicPr>
+            <a:picLocks noChangeAspect="1"/>
+          </p:cNvPicPr>
+          <p:nvPr/>
+        </p:nvPicPr>
+        <p:blipFill>
+          <a:blip r:embed="rId1"/>
+          <a:stretch>
+            <a:fillRect/>
+          </a:stretch>
+        </p:blipFill>
+        <p:spPr>
+          <a:xfrm>
+            <a:off x="7772400" y="201168"/>
+            <a:ext cx="914400" cy="609905"/>
+          </a:xfrm>
+          <a:prstGeom prst="rect">
+            <a:avLst/>
+          </a:prstGeom>
+        </p:spPr>
+      </p:pic>
       <p:sp>
         <p:nvSpPr>
           <p:cNvPr id="25" name="Slide Number Placeholder 0"/>
@@ -2754,7 +2822,7 @@
     <p:bg>
       <p:bgPr>
         <a:solidFill>
-          <a:srgbClr val="0B1F33"/>
+          <a:srgbClr val="1E1640"/>
         </a:solidFill>
       </p:bgPr>
     </p:bg>
@@ -2774,16 +2842,60 @@
       </p:grpSpPr>
       <p:sp>
         <p:nvSpPr>
-          <p:cNvPr id="2" name="Text 0"/>
+          <p:cNvPr id="2" name="Shape 0"/>
+          <p:cNvSpPr/>
+          <p:nvPr/>
+        </p:nvSpPr>
+        <p:spPr>
+          <a:xfrm>
+            <a:off x="548640" y="365760"/>
+            <a:ext cx="1463040" cy="978408"/>
+          </a:xfrm>
+          <a:prstGeom prst="rect">
+            <a:avLst/>
+          </a:prstGeom>
+          <a:solidFill>
+            <a:srgbClr val="FFFFFF"/>
+          </a:solidFill>
+          <a:ln/>
+        </p:spPr>
+      </p:sp>
+      <p:pic>
+        <p:nvPicPr>
+          <p:cNvPr id="3" name="Image 0" descr="/home/user/arctic_presentation_2026_10_20/logo.png">    </p:cNvPr>
+          <p:cNvPicPr>
+            <a:picLocks noChangeAspect="1"/>
+          </p:cNvPicPr>
+          <p:nvPr/>
+        </p:nvPicPr>
+        <p:blipFill>
+          <a:blip r:embed="rId1"/>
+          <a:stretch>
+            <a:fillRect/>
+          </a:stretch>
+        </p:blipFill>
+        <p:spPr>
+          <a:xfrm>
+            <a:off x="594360" y="402336"/>
+            <a:ext cx="1371600" cy="914400"/>
+          </a:xfrm>
+          <a:prstGeom prst="rect">
+            <a:avLst/>
+          </a:prstGeom>
+        </p:spPr>
+      </p:pic>
+      <p:sp>
+        <p:nvSpPr>
+          <p:cNvPr id="4" name="Text 1"/>
           <p:cNvSpPr/>
           <p:nvPr>
-            <p:ph idx="100" type="title" hasCustomPrompt="1"/>
+            <p:ph idx="102" type="title" hasCustomPrompt="1"/>
           </p:nvPr>
         </p:nvSpPr>
         <p:spPr>
           <a:xfrm>
-            <a:off x="548640" y="1097280"/>
-            <a:ext cx="5669280" cy="1463040"/>
+            <a:off x="548640" y="1600200"/>
+            <a:ext cx="5669280" cy="1280160"/>
           </a:xfrm>
           <a:prstGeom prst="rect">
             <a:avLst/>
@@ -3249,16 +3361,16 @@
       </p:sp>
       <p:sp>
         <p:nvSpPr>
-          <p:cNvPr id="6" name="Text 0"/>
+          <p:cNvPr id="6" name="Text 1"/>
           <p:cNvSpPr/>
           <p:nvPr>
-            <p:ph idx="100" type="title" hasCustomPrompt="1"/>
+            <p:ph idx="102" type="title" hasCustomPrompt="1"/>
           </p:nvPr>
         </p:nvSpPr>
         <p:spPr>
           <a:xfrm>
-            <a:off x="548640" y="1097280"/>
-            <a:ext cx="5669280" cy="1463040"/>
+            <a:off x="548640" y="1600200"/>
+            <a:ext cx="5669280" cy="1280160"/>
           </a:xfrm>
           <a:prstGeom prst="rect">
             <a:avLst/>
@@ -3293,7 +3405,7 @@
         </p:nvSpPr>
         <p:spPr>
           <a:xfrm>
-            <a:off x="548640" y="2743200"/>
+            <a:off x="548640" y="3017520"/>
             <a:ext cx="5120640" cy="914400"/>
           </a:xfrm>
           <a:prstGeom prst="rect">
@@ -3329,8 +3441,8 @@
         </p:nvSpPr>
         <p:spPr>
           <a:xfrm>
-            <a:off x="548640" y="4206240"/>
-            <a:ext cx="5486400" cy="320040"/>
+            <a:off x="548640" y="4297680"/>
+            <a:ext cx="5943600" cy="320040"/>
           </a:xfrm>
           <a:prstGeom prst="rect">
             <a:avLst/>
@@ -3351,7 +3463,7 @@
                   <a:schemeClr val="bg2"/>
                 </a:solidFill>
               </a:rPr>
-              <a:t>Доклад для капитанов и берегового офиса  ·  октябрь 2026</a:t>
+              <a:t>Северный проект  ·  Доклад для капитанов и берегового офиса  ·  октябрь 2026</a:t>
             </a:r>
             <a:endParaRPr lang="en-US" sz="1200" dirty="0"/>
           </a:p>
@@ -3393,7 +3505,7 @@
         <p:spPr>
           <a:xfrm>
             <a:off x="457200" y="274320"/>
-            <a:ext cx="8229600" cy="731520"/>
+            <a:ext cx="7132320" cy="731520"/>
           </a:xfrm>
           <a:prstGeom prst="rect">
             <a:avLst/>
@@ -3564,7 +3676,7 @@
                   <a:schemeClr val="tx1"/>
                 </a:solidFill>
               </a:rPr>
-              <a:t>Исключительное право судов под российским флагом на перевозку нефти, газа, СПГ, конденсата и угля по СМП. Требование строить такие суда в РФ (с 01.03.2026) пытались отсрочить: статус уточнить.</a:t>
+              <a:t>Исключительное право судов под российским флагом на перевозку нефти, газа, СПГ, конденсата и угля по СМП: наш конденсат подпадает. Требование строить такие суда в РФ (с 01.03.2026) пытались отсрочить: статус уточнить.</a:t>
             </a:r>
             <a:endParaRPr lang="en-US" sz="1400" dirty="0"/>
           </a:p>
@@ -3864,7 +3976,7 @@
                   <a:schemeClr val="bg1"/>
                 </a:solidFill>
               </a:rPr>
-              <a:t>Проверка контрагента и груза, страховое покрытие, платёжный канал и порты захода. Решаем до подписания чартера.</a:t>
+              <a:t>Арктик СПГ-2 под санкциями: проверка контрагента, страховое покрытие, платёжный канал и порты захода. Решаем до подписания чартера.</a:t>
             </a:r>
             <a:endParaRPr lang="en-US" sz="1400" dirty="0"/>
           </a:p>
@@ -3987,7 +4099,7 @@
         <p:spPr>
           <a:xfrm>
             <a:off x="457200" y="274320"/>
-            <a:ext cx="8229600" cy="731520"/>
+            <a:ext cx="7132320" cy="731520"/>
           </a:xfrm>
           <a:prstGeom prst="rect">
             <a:avLst/>
@@ -4008,7 +4120,7 @@
                   <a:schemeClr val="tx1"/>
                 </a:solidFill>
               </a:rPr>
-              <a:t>Светофор: идти, ждать, отказаться</a:t>
+              <a:t>Светофор решения по рейсу</a:t>
             </a:r>
             <a:endParaRPr lang="en-US" sz="2800" dirty="0"/>
           </a:p>
@@ -4531,7 +4643,7 @@
         <p:spPr>
           <a:xfrm>
             <a:off x="457200" y="274320"/>
-            <a:ext cx="8229600" cy="731520"/>
+            <a:ext cx="7132320" cy="731520"/>
           </a:xfrm>
           <a:prstGeom prst="rect">
             <a:avLst/>
@@ -4922,7 +5034,7 @@
                   <a:schemeClr val="accent4"/>
                 </a:solidFill>
               </a:rPr>
-              <a:t>Какие рейсы по СМП реально окупаются для нашего флота и в какой сезон?</a:t>
+              <a:t>Где граница выгодности зимнего рейса за конденсатом при росте цены проводки?</a:t>
             </a:r>
             <a:endParaRPr lang="en-US" sz="1400" dirty="0"/>
           </a:p>
@@ -4940,7 +5052,7 @@
                   <a:schemeClr val="accent4"/>
                 </a:solidFill>
               </a:rPr>
-              <a:t>Где предел цены проводки, после которого мы идём другим маршрутом?</a:t>
+              <a:t>Северный завоз при едином операторе: рост загрузки или рост зависимости?</a:t>
             </a:r>
             <a:endParaRPr lang="en-US" sz="1400" dirty="0"/>
           </a:p>
@@ -5045,7 +5157,7 @@
         <p:spPr>
           <a:xfrm>
             <a:off x="457200" y="274320"/>
-            <a:ext cx="8229600" cy="731520"/>
+            <a:ext cx="7132320" cy="731520"/>
           </a:xfrm>
           <a:prstGeom prst="rect">
             <a:avLst/>
@@ -5450,7 +5562,7 @@
         <p:spPr>
           <a:xfrm>
             <a:off x="457200" y="274320"/>
-            <a:ext cx="8229600" cy="731520"/>
+            <a:ext cx="7132320" cy="731520"/>
           </a:xfrm>
           <a:prstGeom prst="rect">
             <a:avLst/>
@@ -6041,7 +6153,7 @@
         <p:spPr>
           <a:xfrm>
             <a:off x="457200" y="274320"/>
-            <a:ext cx="8229600" cy="731520"/>
+            <a:ext cx="7132320" cy="731520"/>
           </a:xfrm>
           <a:prstGeom prst="rect">
             <a:avLst/>
@@ -6492,7 +6604,7 @@
         <p:spPr>
           <a:xfrm>
             <a:off x="457200" y="274320"/>
-            <a:ext cx="8229600" cy="731520"/>
+            <a:ext cx="7132320" cy="731520"/>
           </a:xfrm>
           <a:prstGeom prst="rect">
             <a:avLst/>
@@ -6899,7 +7011,7 @@
                   <a:schemeClr val="tx1"/>
                 </a:solidFill>
               </a:rPr>
-              <a:t>Основа потока — внутренние отгрузки (СПГ, нефть, уголь), а не транзит.</a:t>
+              <a:t>Основа потока — внутренние отгрузки (СПГ, конденсат, уголь), а не транзит.</a:t>
             </a:r>
             <a:endParaRPr lang="en-US" sz="1400" dirty="0"/>
           </a:p>
@@ -6917,7 +7029,7 @@
                   <a:schemeClr val="tx1"/>
                 </a:solidFill>
               </a:rPr>
-              <a:t>Контейнерный сервис Китай–Европа в 2026 стал регулярным, но сезонным.</a:t>
+              <a:t>Наши танкеры работают в основном сегменте: зимой конденсат Ямала, летом северный завоз.</a:t>
             </a:r>
             <a:endParaRPr lang="en-US" sz="1400" dirty="0"/>
           </a:p>
@@ -7058,7 +7170,7 @@
         <p:spPr>
           <a:xfrm>
             <a:off x="457200" y="274320"/>
-            <a:ext cx="8229600" cy="731520"/>
+            <a:ext cx="7132320" cy="731520"/>
           </a:xfrm>
           <a:prstGeom prst="rect">
             <a:avLst/>
@@ -7860,7 +7972,7 @@
         <p:spPr>
           <a:xfrm>
             <a:off x="457200" y="274320"/>
-            <a:ext cx="8229600" cy="731520"/>
+            <a:ext cx="7132320" cy="731520"/>
           </a:xfrm>
           <a:prstGeom prst="rect">
             <a:avLst/>
@@ -8205,7 +8317,7 @@
         <p:spPr>
           <a:xfrm>
             <a:off x="457200" y="274320"/>
-            <a:ext cx="8229600" cy="731520"/>
+            <a:ext cx="7132320" cy="731520"/>
           </a:xfrm>
           <a:prstGeom prst="rect">
             <a:avLst/>
@@ -8226,7 +8338,7 @@
                   <a:schemeClr val="tx1"/>
                 </a:solidFill>
               </a:rPr>
-              <a:t>Рейс по СМП: что на весах</a:t>
+              <a:t>Наши танкеры: лето и зима</a:t>
             </a:r>
             <a:endParaRPr lang="en-US" sz="2800" dirty="0"/>
           </a:p>
@@ -8234,18 +8346,18 @@
       </p:sp>
       <p:sp>
         <p:nvSpPr>
-          <p:cNvPr id="3" name="Показатель"/>
+          <p:cNvPr id="3" name="Карточка"/>
           <p:cNvSpPr/>
           <p:nvPr/>
         </p:nvSpPr>
         <p:spPr>
           <a:xfrm>
             <a:off x="457200" y="1188720"/>
-            <a:ext cx="2468880" cy="1371600"/>
+            <a:ext cx="4023360" cy="2834640"/>
           </a:xfrm>
           <a:prstGeom prst="roundRect">
             <a:avLst>
-              <a:gd name="adj" fmla="val 5333"/>
+              <a:gd name="adj" fmla="val 2581"/>
             </a:avLst>
           </a:prstGeom>
           <a:solidFill>
@@ -8256,42 +8368,23 @@
       </p:sp>
       <p:sp>
         <p:nvSpPr>
-          <p:cNvPr id="4" name="Text 2"/>
-          <p:cNvSpPr txBox="1"/>
-          <p:nvPr/>
-        </p:nvSpPr>
-        <p:spPr>
-          <a:xfrm>
-            <a:off x="594360" y="1261872"/>
-            <a:ext cx="2194560" cy="502920"/>
-          </a:xfrm>
-          <a:prstGeom prst="rect">
-            <a:avLst/>
-          </a:prstGeom>
-          <a:noFill/>
-          <a:ln/>
-        </p:spPr>
-        <p:txBody>
-          <a:bodyPr wrap="square" lIns="0" tIns="0" rIns="0" bIns="0" rtlCol="0" anchor="ctr"/>
-          <a:lstStyle/>
-          <a:p>
-            <a:pPr indent="0" marL="0">
-              <a:buNone/>
-            </a:pPr>
-            <a:r>
-              <a:rPr lang="en-US" sz="3000" b="1" dirty="0">
-                <a:solidFill>
-                  <a:schemeClr val="accent1"/>
-                </a:solidFill>
-                <a:latin typeface="Cambria" pitchFamily="34" charset="0"/>
-                <a:ea typeface="Cambria" pitchFamily="34" charset="-122"/>
-                <a:cs typeface="Cambria" pitchFamily="34" charset="-120"/>
-              </a:rPr>
-              <a:t>≈21 день</a:t>
-            </a:r>
-            <a:endParaRPr lang="en-US" sz="3000" dirty="0"/>
-          </a:p>
-        </p:txBody>
+          <p:cNvPr id="4" name="Сезон 1"/>
+          <p:cNvSpPr/>
+          <p:nvPr/>
+        </p:nvSpPr>
+        <p:spPr>
+          <a:xfrm>
+            <a:off x="594360" y="1325880"/>
+            <a:ext cx="384048" cy="384048"/>
+          </a:xfrm>
+          <a:prstGeom prst="ellipse">
+            <a:avLst/>
+          </a:prstGeom>
+          <a:solidFill>
+            <a:schemeClr val="accent1"/>
+          </a:solidFill>
+          <a:ln/>
+        </p:spPr>
       </p:sp>
       <p:sp>
         <p:nvSpPr>
@@ -8301,8 +8394,44 @@
         </p:nvSpPr>
         <p:spPr>
           <a:xfrm>
-            <a:off x="594360" y="1810512"/>
-            <a:ext cx="2194560" cy="676656"/>
+            <a:off x="1097280" y="1325880"/>
+            <a:ext cx="3291840" cy="384048"/>
+          </a:xfrm>
+          <a:prstGeom prst="rect">
+            <a:avLst/>
+          </a:prstGeom>
+          <a:noFill/>
+          <a:ln/>
+        </p:spPr>
+        <p:txBody>
+          <a:bodyPr wrap="square" lIns="0" tIns="0" rIns="0" bIns="0" rtlCol="0" anchor="ctr"/>
+          <a:lstStyle/>
+          <a:p>
+            <a:pPr indent="0" marL="0">
+              <a:buNone/>
+            </a:pPr>
+            <a:r>
+              <a:rPr lang="en-US" sz="1800" b="1" dirty="0">
+                <a:solidFill>
+                  <a:schemeClr val="tx1"/>
+                </a:solidFill>
+              </a:rPr>
+              <a:t>Лето: северный завоз</a:t>
+            </a:r>
+            <a:endParaRPr lang="en-US" sz="1800" dirty="0"/>
+          </a:p>
+        </p:txBody>
+      </p:sp>
+      <p:sp>
+        <p:nvSpPr>
+          <p:cNvPr id="6" name="Text 4"/>
+          <p:cNvSpPr txBox="1"/>
+          <p:nvPr/>
+        </p:nvSpPr>
+        <p:spPr>
+          <a:xfrm>
+            <a:off x="594360" y="1874520"/>
+            <a:ext cx="3749040" cy="2057400"/>
           </a:xfrm>
           <a:prstGeom prst="rect">
             <a:avLst/>
@@ -8314,8 +8443,12 @@
           <a:bodyPr wrap="square" lIns="0" tIns="0" rIns="0" bIns="0" rtlCol="0" anchor="t"/>
           <a:lstStyle/>
           <a:p>
-            <a:pPr indent="0" marL="0">
-              <a:buNone/>
+            <a:pPr marL="342900" indent="-342900">
+              <a:spcAft>
+                <a:spcPts val="600"/>
+              </a:spcAft>
+              <a:buSzPct val="100000"/>
+              <a:buChar char="•"/>
             </a:pPr>
             <a:r>
               <a:rPr lang="en-US" sz="1400" dirty="0">
@@ -8323,26 +8456,62 @@
                   <a:schemeClr val="tx1"/>
                 </a:solidFill>
               </a:rPr>
-              <a:t>Ningbo–Felixstowe по СМП</a:t>
+              <a:t>«Росатом Арктика» — единый оператор северного завоза с 2026 г.</a:t>
             </a:r>
             <a:endParaRPr lang="en-US" sz="1400" dirty="0"/>
           </a:p>
-        </p:txBody>
-      </p:sp>
-      <p:sp>
-        <p:nvSpPr>
-          <p:cNvPr id="6" name="Показатель"/>
+          <a:p>
+            <a:pPr marL="342900" indent="-342900">
+              <a:spcAft>
+                <a:spcPts val="600"/>
+              </a:spcAft>
+              <a:buSzPct val="100000"/>
+              <a:buChar char="•"/>
+            </a:pPr>
+            <a:r>
+              <a:rPr lang="en-US" sz="1400" dirty="0">
+                <a:solidFill>
+                  <a:schemeClr val="tx1"/>
+                </a:solidFill>
+              </a:rPr>
+              <a:t>Подтверждено 264 тыс. т на 2026 г., +65% к 2025 г.</a:t>
+            </a:r>
+            <a:endParaRPr lang="en-US" sz="1400" dirty="0"/>
+          </a:p>
+          <a:p>
+            <a:pPr marL="342900" indent="-342900">
+              <a:spcAft>
+                <a:spcPts val="600"/>
+              </a:spcAft>
+              <a:buSzPct val="100000"/>
+              <a:buChar char="•"/>
+            </a:pPr>
+            <a:r>
+              <a:rPr lang="en-US" sz="1400" dirty="0">
+                <a:solidFill>
+                  <a:schemeClr val="tx1"/>
+                </a:solidFill>
+              </a:rPr>
+              <a:t>Окно короткое: график зависит от ледовой обстановки на трассе</a:t>
+            </a:r>
+            <a:endParaRPr lang="en-US" sz="1400" dirty="0"/>
+          </a:p>
+        </p:txBody>
+      </p:sp>
+      <p:sp>
+        <p:nvSpPr>
+          <p:cNvPr id="7" name="Карточка"/>
           <p:cNvSpPr/>
           <p:nvPr/>
         </p:nvSpPr>
         <p:spPr>
           <a:xfrm>
-            <a:off x="457200" y="2697480"/>
-            <a:ext cx="2468880" cy="1371600"/>
+            <a:off x="4663440" y="1188720"/>
+            <a:ext cx="4023360" cy="2834640"/>
           </a:xfrm>
           <a:prstGeom prst="roundRect">
             <a:avLst>
-              <a:gd name="adj" fmla="val 5333"/>
+              <a:gd name="adj" fmla="val 2581"/>
             </a:avLst>
           </a:prstGeom>
           <a:solidFill>
@@ -8353,14 +8522,34 @@
       </p:sp>
       <p:sp>
         <p:nvSpPr>
-          <p:cNvPr id="7" name="Text 5"/>
+          <p:cNvPr id="8" name="Сезон 2"/>
+          <p:cNvSpPr/>
+          <p:nvPr/>
+        </p:nvSpPr>
+        <p:spPr>
+          <a:xfrm>
+            <a:off x="4800600" y="1325880"/>
+            <a:ext cx="384048" cy="384048"/>
+          </a:xfrm>
+          <a:prstGeom prst="ellipse">
+            <a:avLst/>
+          </a:prstGeom>
+          <a:solidFill>
+            <a:schemeClr val="accent3"/>
+          </a:solidFill>
+          <a:ln/>
+        </p:spPr>
+      </p:sp>
+      <p:sp>
+        <p:nvSpPr>
+          <p:cNvPr id="9" name="Text 7"/>
           <p:cNvSpPr txBox="1"/>
           <p:nvPr/>
         </p:nvSpPr>
         <p:spPr>
           <a:xfrm>
-            <a:off x="594360" y="2770632"/>
-            <a:ext cx="2194560" cy="502920"/>
+            <a:off x="5303520" y="1325880"/>
+            <a:ext cx="3291840" cy="384048"/>
           </a:xfrm>
           <a:prstGeom prst="rect">
             <a:avLst/>
@@ -8376,77 +8565,16 @@
               <a:buNone/>
             </a:pPr>
             <a:r>
-              <a:rPr lang="en-US" sz="3000" b="1" dirty="0">
-                <a:solidFill>
-                  <a:schemeClr val="accent1"/>
-                </a:solidFill>
-                <a:latin typeface="Cambria" pitchFamily="34" charset="0"/>
-                <a:ea typeface="Cambria" pitchFamily="34" charset="-122"/>
-                <a:cs typeface="Cambria" pitchFamily="34" charset="-120"/>
-              </a:rPr>
-              <a:t>38–45 дней</a:t>
-            </a:r>
-            <a:endParaRPr lang="en-US" sz="3000" dirty="0"/>
-          </a:p>
-        </p:txBody>
-      </p:sp>
-      <p:sp>
-        <p:nvSpPr>
-          <p:cNvPr id="8" name="Text 6"/>
-          <p:cNvSpPr txBox="1"/>
-          <p:nvPr/>
-        </p:nvSpPr>
-        <p:spPr>
-          <a:xfrm>
-            <a:off x="594360" y="3319272"/>
-            <a:ext cx="2194560" cy="676656"/>
-          </a:xfrm>
-          <a:prstGeom prst="rect">
-            <a:avLst/>
-          </a:prstGeom>
-          <a:noFill/>
-          <a:ln/>
-        </p:spPr>
-        <p:txBody>
-          <a:bodyPr wrap="square" lIns="0" tIns="0" rIns="0" bIns="0" rtlCol="0" anchor="t"/>
-          <a:lstStyle/>
-          <a:p>
-            <a:pPr indent="0" marL="0">
-              <a:buNone/>
-            </a:pPr>
-            <a:r>
-              <a:rPr lang="en-US" sz="1400" dirty="0">
+              <a:rPr lang="en-US" sz="1800" b="1" dirty="0">
                 <a:solidFill>
                   <a:schemeClr val="tx1"/>
                 </a:solidFill>
               </a:rPr>
-              <a:t>тот же рейс через Суэц</a:t>
-            </a:r>
-            <a:endParaRPr lang="en-US" sz="1400" dirty="0"/>
-          </a:p>
-        </p:txBody>
-      </p:sp>
-      <p:sp>
-        <p:nvSpPr>
-          <p:cNvPr id="9" name="Карточка"/>
-          <p:cNvSpPr/>
-          <p:nvPr/>
-        </p:nvSpPr>
-        <p:spPr>
-          <a:xfrm>
-            <a:off x="3108960" y="1188720"/>
-            <a:ext cx="2743200" cy="2880360"/>
-          </a:xfrm>
-          <a:prstGeom prst="roundRect">
-            <a:avLst>
-              <a:gd name="adj" fmla="val 2667"/>
-            </a:avLst>
-          </a:prstGeom>
-          <a:solidFill>
-            <a:schemeClr val="bg2"/>
-          </a:solidFill>
-          <a:ln/>
-        </p:spPr>
+              <a:t>Зима: вывоз конденсата</a:t>
+            </a:r>
+            <a:endParaRPr lang="en-US" sz="1800" dirty="0"/>
+          </a:p>
+        </p:txBody>
       </p:sp>
       <p:sp>
         <p:nvSpPr>
@@ -8456,8 +8584,8 @@
         </p:nvSpPr>
         <p:spPr>
           <a:xfrm>
-            <a:off x="3246120" y="1280160"/>
-            <a:ext cx="2468880" cy="2651760"/>
+            <a:off x="4800600" y="1874520"/>
+            <a:ext cx="3749040" cy="2057400"/>
           </a:xfrm>
           <a:prstGeom prst="rect">
             <a:avLst/>
@@ -8468,27 +8596,10 @@
         <p:txBody>
           <a:bodyPr wrap="square" lIns="0" tIns="0" rIns="0" bIns="0" rtlCol="0" anchor="t"/>
           <a:lstStyle/>
-          <a:p>
-            <a:pPr indent="0" marL="0">
-              <a:spcAft>
-                <a:spcPts val="400"/>
-              </a:spcAft>
-              <a:buNone/>
-            </a:pPr>
-            <a:r>
-              <a:rPr lang="en-US" sz="1400" b="1" dirty="0">
-                <a:solidFill>
-                  <a:schemeClr val="accent6"/>
-                </a:solidFill>
-              </a:rPr>
-              <a:t>Даёт СМП</a:t>
-            </a:r>
-            <a:endParaRPr lang="en-US" sz="1400" dirty="0"/>
-          </a:p>
           <a:p>
             <a:pPr marL="342900" indent="-342900">
               <a:spcAft>
-                <a:spcPts val="400"/>
+                <a:spcPts val="600"/>
               </a:spcAft>
               <a:buSzPct val="100000"/>
               <a:buChar char="•"/>
@@ -8499,14 +8610,14 @@
                   <a:schemeClr val="tx1"/>
                 </a:solidFill>
               </a:rPr>
-              <a:t>Меньше суток в рейсе</a:t>
+              <a:t>Ямал СПГ и Арктик СПГ-2; перевозка конденсата только под российским флагом</a:t>
             </a:r>
             <a:endParaRPr lang="en-US" sz="1400" dirty="0"/>
           </a:p>
           <a:p>
             <a:pPr marL="342900" indent="-342900">
               <a:spcAft>
-                <a:spcPts val="400"/>
+                <a:spcPts val="600"/>
               </a:spcAft>
               <a:buSzPct val="100000"/>
               <a:buChar char="•"/>
@@ -8517,14 +8628,14 @@
                   <a:schemeClr val="tx1"/>
                 </a:solidFill>
               </a:rPr>
-              <a:t>Меньше топлива и фрахтовой нагрузки</a:t>
+              <a:t>Ледокольная проводка и ледовый класс — главные статьи затрат и риска</a:t>
             </a:r>
             <a:endParaRPr lang="en-US" sz="1400" dirty="0"/>
           </a:p>
           <a:p>
             <a:pPr marL="342900" indent="-342900">
               <a:spcAft>
-                <a:spcPts val="400"/>
+                <a:spcPts val="600"/>
               </a:spcAft>
               <a:buSzPct val="100000"/>
               <a:buChar char="•"/>
@@ -8535,7 +8646,7 @@
                   <a:schemeClr val="tx1"/>
                 </a:solidFill>
               </a:rPr>
-              <a:t>Исключительное право РФ-флага на углеводороды</a:t>
+              <a:t>Арктик СПГ-2 под санкциями; отгрузки растут: СПГ 3,6 млн т к 12.10.2026</a:t>
             </a:r>
             <a:endParaRPr lang="en-US" sz="1400" dirty="0"/>
           </a:p>
@@ -8549,140 +8660,7 @@
         </p:nvSpPr>
         <p:spPr>
           <a:xfrm>
-            <a:off x="5943600" y="1188720"/>
-            <a:ext cx="2743200" cy="2880360"/>
-          </a:xfrm>
-          <a:prstGeom prst="roundRect">
-            <a:avLst>
-              <a:gd name="adj" fmla="val 2667"/>
-            </a:avLst>
-          </a:prstGeom>
-          <a:solidFill>
-            <a:schemeClr val="bg2"/>
-          </a:solidFill>
-          <a:ln/>
-        </p:spPr>
-      </p:sp>
-      <p:sp>
-        <p:nvSpPr>
-          <p:cNvPr id="12" name="Text 10"/>
-          <p:cNvSpPr txBox="1"/>
-          <p:nvPr/>
-        </p:nvSpPr>
-        <p:spPr>
-          <a:xfrm>
-            <a:off x="6080760" y="1280160"/>
-            <a:ext cx="2468880" cy="2651760"/>
-          </a:xfrm>
-          <a:prstGeom prst="rect">
-            <a:avLst/>
-          </a:prstGeom>
-          <a:noFill/>
-          <a:ln/>
-        </p:spPr>
-        <p:txBody>
-          <a:bodyPr wrap="square" lIns="0" tIns="0" rIns="0" bIns="0" rtlCol="0" anchor="t"/>
-          <a:lstStyle/>
-          <a:p>
-            <a:pPr indent="0" marL="0">
-              <a:spcAft>
-                <a:spcPts val="400"/>
-              </a:spcAft>
-              <a:buNone/>
-            </a:pPr>
-            <a:r>
-              <a:rPr lang="en-US" sz="1400" b="1" dirty="0">
-                <a:solidFill>
-                  <a:schemeClr val="accent5"/>
-                </a:solidFill>
-              </a:rPr>
-              <a:t>Берёт СМП</a:t>
-            </a:r>
-            <a:endParaRPr lang="en-US" sz="1400" dirty="0"/>
-          </a:p>
-          <a:p>
-            <a:pPr marL="342900" indent="-342900">
-              <a:spcAft>
-                <a:spcPts val="400"/>
-              </a:spcAft>
-              <a:buSzPct val="100000"/>
-              <a:buChar char="•"/>
-            </a:pPr>
-            <a:r>
-              <a:rPr lang="en-US" sz="1400" dirty="0">
-                <a:solidFill>
-                  <a:schemeClr val="tx1"/>
-                </a:solidFill>
-              </a:rPr>
-              <a:t>Проводка и возможный сбор</a:t>
-            </a:r>
-            <a:endParaRPr lang="en-US" sz="1400" dirty="0"/>
-          </a:p>
-          <a:p>
-            <a:pPr marL="342900" indent="-342900">
-              <a:spcAft>
-                <a:spcPts val="400"/>
-              </a:spcAft>
-              <a:buSzPct val="100000"/>
-              <a:buChar char="•"/>
-            </a:pPr>
-            <a:r>
-              <a:rPr lang="en-US" sz="1400" dirty="0">
-                <a:solidFill>
-                  <a:schemeClr val="tx1"/>
-                </a:solidFill>
-              </a:rPr>
-              <a:t>Ледовый класс, страховая надбавка</a:t>
-            </a:r>
-            <a:endParaRPr lang="en-US" sz="1400" dirty="0"/>
-          </a:p>
-          <a:p>
-            <a:pPr marL="342900" indent="-342900">
-              <a:spcAft>
-                <a:spcPts val="400"/>
-              </a:spcAft>
-              <a:buSzPct val="100000"/>
-              <a:buChar char="•"/>
-            </a:pPr>
-            <a:r>
-              <a:rPr lang="en-US" sz="1400" dirty="0">
-                <a:solidFill>
-                  <a:schemeClr val="tx1"/>
-                </a:solidFill>
-              </a:rPr>
-              <a:t>Ожидание ледокола, окно навигации</a:t>
-            </a:r>
-            <a:endParaRPr lang="en-US" sz="1400" dirty="0"/>
-          </a:p>
-          <a:p>
-            <a:pPr marL="342900" indent="-342900">
-              <a:spcAft>
-                <a:spcPts val="400"/>
-              </a:spcAft>
-              <a:buSzPct val="100000"/>
-              <a:buChar char="•"/>
-            </a:pPr>
-            <a:r>
-              <a:rPr lang="en-US" sz="1400" dirty="0">
-                <a:solidFill>
-                  <a:schemeClr val="tx1"/>
-                </a:solidFill>
-              </a:rPr>
-              <a:t>Риск повреждения и буксировки</a:t>
-            </a:r>
-            <a:endParaRPr lang="en-US" sz="1400" dirty="0"/>
-          </a:p>
-        </p:txBody>
-      </p:sp>
-      <p:sp>
-        <p:nvSpPr>
-          <p:cNvPr id="13" name="Карточка"/>
-          <p:cNvSpPr/>
-          <p:nvPr/>
-        </p:nvSpPr>
-        <p:spPr>
-          <a:xfrm>
-            <a:off x="457200" y="4206240"/>
+            <a:off x="457200" y="4160520"/>
             <a:ext cx="8229600" cy="457200"/>
           </a:xfrm>
           <a:prstGeom prst="roundRect">
@@ -8698,13 +8676,13 @@
       </p:sp>
       <p:sp>
         <p:nvSpPr>
-          <p:cNvPr id="14" name="Text 12"/>
+          <p:cNvPr id="12" name="Text 10"/>
           <p:cNvSpPr txBox="1"/>
           <p:nvPr/>
         </p:nvSpPr>
         <p:spPr>
           <a:xfrm>
-            <a:off x="640080" y="4206240"/>
+            <a:off x="640080" y="4160520"/>
             <a:ext cx="7863840" cy="457200"/>
           </a:xfrm>
           <a:prstGeom prst="rect">
@@ -8726,7 +8704,7 @@
                   <a:schemeClr val="bg1"/>
                 </a:solidFill>
               </a:rPr>
-              <a:t>Рейс выгоден, если Δдней × стоимость судо-суток &gt; проводка + ледовые надбавки + риск простоя</a:t>
+              <a:t>Маржа сезона = фрахт − (проводка + ледовые надбавки + простои + топливо). Считаем по рейсам</a:t>
             </a:r>
             <a:endParaRPr lang="en-US" sz="1400" dirty="0"/>
           </a:p>
@@ -8734,7 +8712,7 @@
       </p:sp>
       <p:sp>
         <p:nvSpPr>
-          <p:cNvPr id="15" name="Источник"/>
+          <p:cNvPr id="13" name="Источник"/>
           <p:cNvSpPr txBox="1"/>
           <p:nvPr/>
         </p:nvSpPr>
@@ -8762,7 +8740,7 @@
                   <a:schemeClr val="accent3"/>
                 </a:solidFill>
               </a:rPr>
-              <a:t>Источники: Meduza и Carnegie (время рейса, 2026); формула — рабочая модель для обсуждения, цифры подставляет компания</a:t>
+              <a:t>Источники: Росатом Арктика, КТМ РФ, Reuters/LSEG; формула — рабочая модель для обсуждения</a:t>
             </a:r>
             <a:endParaRPr lang="en-US" sz="1000" dirty="0"/>
           </a:p>
@@ -8849,7 +8827,7 @@
         <p:spPr>
           <a:xfrm>
             <a:off x="457200" y="274320"/>
-            <a:ext cx="8229600" cy="731520"/>
+            <a:ext cx="7132320" cy="731520"/>
           </a:xfrm>
           <a:prstGeom prst="rect">
             <a:avLst/>
@@ -9759,7 +9737,7 @@
         <p:spPr>
           <a:xfrm>
             <a:off x="457200" y="274320"/>
-            <a:ext cx="8229600" cy="731520"/>
+            <a:ext cx="7132320" cy="731520"/>
           </a:xfrm>
           <a:prstGeom prst="rect">
             <a:avLst/>
@@ -9780,7 +9758,7 @@
                   <a:schemeClr val="tx1"/>
                 </a:solidFill>
               </a:rPr>
-              <a:t>Лёд 2026: меньше льда ≠ меньше риска</a:t>
+              <a:t>Лёд 2026: риск не уменьшился</a:t>
             </a:r>
             <a:endParaRPr lang="en-US" sz="2800" dirty="0"/>
           </a:p>
@@ -10334,32 +10312,32 @@
 </file>
 
 <file path=ppt/theme/theme1.xml><?xml version="1.0" encoding="utf-8"?>
-<a:theme xmlns:a="http://schemas.openxmlformats.org/drawingml/2006/main" name="Arctic Route">
+<a:theme xmlns:a="http://schemas.openxmlformats.org/drawingml/2006/main" name="Severny Proekt">
   <a:themeElements>
-    <a:clrScheme name="Arctic Route">
+    <a:clrScheme name="Severny Proekt">
       <a:dk1>
-        <a:srgbClr val="0B1F33"/>
+        <a:srgbClr val="1E1640"/>
       </a:dk1>
       <a:lt1>
         <a:srgbClr val="FFFFFF"/>
       </a:lt1>
       <a:dk2>
-        <a:srgbClr val="12395B"/>
+        <a:srgbClr val="3D2F73"/>
       </a:dk2>
       <a:lt2>
-        <a:srgbClr val="EAF3F7"/>
+        <a:srgbClr val="F0EDF7"/>
       </a:lt2>
       <a:accent1>
-        <a:srgbClr val="1B9AAA"/>
+        <a:srgbClr val="3E8E34"/>
       </a:accent1>
       <a:accent2>
         <a:srgbClr val="E8771E"/>
       </a:accent2>
       <a:accent3>
-        <a:srgbClr val="3E6E8E"/>
+        <a:srgbClr val="6B5CA5"/>
       </a:accent3>
       <a:accent4>
-        <a:srgbClr val="7FC8D6"/>
+        <a:srgbClr val="B9AEE0"/>
       </a:accent4>
       <a:accent5>
         <a:srgbClr val="C0392B"/>
@@ -10368,13 +10346,13 @@
         <a:srgbClr val="2E8B5A"/>
       </a:accent6>
       <a:hlink>
-        <a:srgbClr val="1B9AAA"/>
+        <a:srgbClr val="3E8E34"/>
       </a:hlink>
       <a:folHlink>
-        <a:srgbClr val="3E6E8E"/>
+        <a:srgbClr val="6B5CA5"/>
       </a:folHlink>
     </a:clrScheme>
-    <a:fontScheme name="Arctic Route">
+    <a:fontScheme name="Severny Proekt">
       <a:majorFont>
         <a:latin typeface="Cambria"/>
         <a:ea typeface=""/>

</xml_diff>

<commit_message>
Address presentation comments: speaker name, 103 transit passages, dry cargo, icebreakers, PWOM, ice stats, rescue fleet, summary wording
Co-Authored-By: Claude Sonnet 5.5 <noreply@anthropic.com>
Claude-Session: https://claude.ai/code/session_01NknPrkgT7ASbMFec99CZjD
</commit_message>
<xml_diff>
--- a/Arktika_dengi_i_bezopasnost.pptx
+++ b/Arktika_dengi_i_bezopasnost.pptx
@@ -119,38 +119,38 @@
   <p:extLst>
     <p:ext uri="{521415D9-36F7-43E2-AB2F-B90AF26B5E84}">
       <p14:sectionLst xmlns:p14="http://schemas.microsoft.com/office/powerpoint/2010/main">
-        <p14:section name="Вступление" id="{8b1f9ba4-15e8-dda8-3a84-9dbb819e4926}">
+        <p14:section name="Вступление" id="{27dc4dba-08fe-01ae-620d-448acccc284a}">
           <p14:sldIdLst>
             <p14:sldId id="256"/>
             <p14:sldId id="257"/>
           </p14:sldIdLst>
         </p14:section>
-        <p14:section name="Картина" id="{f56cff68-2892-a24a-567d-0236e7eae5f4}">
+        <p14:section name="Картина" id="{705d2267-4eda-a37f-cf4a-3c8be903f442}">
           <p14:sldIdLst>
             <p14:sldId id="258"/>
             <p14:sldId id="259"/>
           </p14:sldIdLst>
         </p14:section>
-        <p14:section name="Деньги" id="{a61560a9-ccb3-84a3-6899-f8df54b599a0}">
+        <p14:section name="Деньги" id="{9da74fce-2bcb-7066-13bd-4f78d6d7c1ee}">
           <p14:sldIdLst>
             <p14:sldId id="260"/>
             <p14:sldId id="261"/>
             <p14:sldId id="262"/>
           </p14:sldIdLst>
         </p14:section>
-        <p14:section name="Безопасность" id="{bb20e653-5674-f3ac-dda6-68693af75441}">
+        <p14:section name="Безопасность" id="{7a259277-c8f0-8cdc-895f-668ccb69fb15}">
           <p14:sldIdLst>
             <p14:sldId id="263"/>
             <p14:sldId id="264"/>
           </p14:sldIdLst>
         </p14:section>
-        <p14:section name="Риски" id="{eb899570-844d-fbea-5fb4-527a80323eb5}">
+        <p14:section name="Риски" id="{4b984e1f-d846-65ec-af76-9824f52396ec}">
           <p14:sldIdLst>
             <p14:sldId id="265"/>
             <p14:sldId id="266"/>
           </p14:sldIdLst>
         </p14:section>
-        <p14:section name="Итоги" id="{9f1b21b6-4786-efea-a3cb-5f94434f70e4}">
+        <p14:section name="Итоги" id="{8c3887d8-8e41-70e6-cc7a-78cc5e72f488}">
           <p14:sldIdLst>
             <p14:sldId id="267"/>
             <p14:sldId id="268"/>
@@ -469,7 +469,7 @@
                 </a:solidFill>
                 <a:latin typeface="+mn-lt"/>
               </a:rPr>
-              <a:t>Контейнерные рейсы китайских перевозчиков по СМП</a:t>
+              <a:t>Контейнерные рейсы китайских перевозчиков (Росатом)</a:t>
             </a:r>
           </a:p>
         </c:rich>
@@ -747,7 +747,7 @@
                 </a:solidFill>
                 <a:latin typeface="+mn-lt"/>
               </a:rPr>
-              <a:t>Суточный тариф проводки новыми ледоколами, млн ₽</a:t>
+              <a:t>Суточный тариф проводки новыми ледоколами, млн ₽ в сутки</a:t>
             </a:r>
           </a:p>
         </c:rich>
@@ -814,13 +814,13 @@
                 <c:ptCount val="3"/>
                 <c:lvl>
                   <c:pt idx="0">
-                    <c:v>Готовы платить</c:v>
+                    <c:v>Готовы платить грузоотправители</c:v>
                   </c:pt>
                   <c:pt idx="1">
-                    <c:v>Со сбором (расчёт)</c:v>
+                    <c:v>Расчёт со сбором</c:v>
                   </c:pt>
                   <c:pt idx="2">
-                    <c:v>Без сбора</c:v>
+                    <c:v>Расчёт без сбора</c:v>
                   </c:pt>
                 </c:lvl>
               </c:multiLvlStrCache>
@@ -1388,7 +1388,7 @@
           <a:p>
             <a:r>
               <a:rPr lang="en-US" dirty="0"/>
-              <a:t>[0:30] Добрый день, коллеги. Тема — Арктика через призму двух вещей, которые в нашей профессии вечно спорят: деньги и безопасность. Формат: 15 минут рассказа, по ходу несколько вопросов к залу — отвечайте с места, мне важнее ваш опыт, чем мой слайд. Потом 15 минут обсуждения. Данные — на октябрь 2026, по официальным источникам: Росатом, Минтранс, Минвостокразвития, Правительство, плюс международные для сверки. Где источники расходятся — скажу прямо.</a:t>
+              <a:t>[0:30] Добрый день, коллеги. Меня зовут Михаил Георгиевич Пицуков, я менеджер департамента танкерных перевозок. Тема — Арктика через призму двух вещей, которые в нашей профессии вечно спорят: деньги и безопасность. Формат: 15 минут рассказа, по ходу несколько вопросов к залу — отвечайте с места, мне важнее ваш опыт, чем мой слайд. Потом 15 минут обсуждения. Данные — на октябрь 2026, по официальным источникам: Росатом, Минтранс, Минвостокразвития, Правительство, плюс международные для сверки. Где источники расходятся — скажу прямо.</a:t>
             </a:r>
             <a:endParaRPr lang="en-US" dirty="0"/>
           </a:p>
@@ -1652,7 +1652,7 @@
           <a:p>
             <a:r>
               <a:rPr lang="en-US" dirty="0"/>
-              <a:t>[0:30 + 15 мин Q&amp;A] Три мысли. Поток держится на внутренних отгрузках, не на транзите. Деньги в проводке — следите за сбором и тарифами. Safety — порядок: сначала закрыть замки, потом считать. Дальше ваши вопросы. Если пауза — используйте три заготовленных. Приложение с источниками — на следующем слайде.</a:t>
+              <a:t>[0:30 + 15 мин Q&amp;A] Три мысли. Поток держится на внутренних отгрузках, не на транзите; 40+ млн т — это прогноз Росатома на 2026 год, Минтранс осторожнее (38,2). Деньги: ледокольная проводка дорожает; речь о проекте ледосбора на достройку ледоколов — 20,07 рубля за тонну экспортного груза до 2036 года — и о новом тарифе. Safety — порядок: сначала закрыть замки, потом считать. Дальше ваши вопросы. Если пауза — используйте три заготовленных. Приложение с источниками — на следующем слайде.</a:t>
             </a:r>
             <a:endParaRPr lang="en-US" dirty="0"/>
           </a:p>
@@ -2004,7 +2004,7 @@
           <a:p>
             <a:r>
               <a:rPr lang="en-US" dirty="0"/>
-              <a:t>[1:30] Возвращаемся к вопросу. Правильный ответ — Б: транзит Азия–Европа это 3,2 млн т из 37, то есть меньше 9%. Основа потока — вывоз с Ямала и Гыдана и северный завоз. Россия—Китай — ещё 5,4 млн т, около 15%. Контейнеры растут: 7, 14, 24 рейса, в 2026 планируют 30 и больше; с 15 августа 2026 первый в истории регулярный сервис Ningbo–Felixstowe с расписанием, около 21 дня в пути против 38–45 через Суэц. За сезон по данным китайской таможни — 8 рейсов и около 7,8 тыс. TEU; потом пауза до лета 2027. Наши танкеры работают как раз в основном сегменте потока: зимой вывоз конденсата, летом северный завоз. А вот для сухогрузов тревожный сигнал: сухие грузы в портах Арктического бассейна за 10 месяцев 2025 года упали на 16,4%. Спросите зал: кто из вас видит этот спад в своих рейсах?</a:t>
+              <a:t>[1:30] Возвращаемся к вопросу. Правильный ответ — Б: сквозной транзит по Севморпути — 3,2 млн т из 37, то есть меньше 9%. Основа потока — вывоз углеводородов (по данным Востокгосплана, 86% потока — СПГ, нефть, нефтепродукты) и северный завоз. Россия—Китай — ещё 5,4 млн т, около 15%. Откуда 103 прохода: это не контейнерные рейсы. По оценке CHNL (не официальные данные) в 2025 г. это 34 танкера, 23 навалочных судна, 15 контейнеровозов, 12 судов генгруза, 7 рыболовных, 5 газовозов, 3 рефрижераторных и 4 прочих. Считаются проходы в обе стороны, многие — в балласте. Отдельно, контейнерные рейсы китайских перевозчиков (7, 14, 24 и план 30+) — другая статистика Росатома: туда входят и рейсы между портами России и Китая, не только транзит Азия–Европа. Методики разные, поэтому цифры не складываются. Про −18,3%: это абсолютный объём перевалки сухих грузов в портах Арктического бассейна (АСОП): 21,3 млн т в 2025 г. против 26 млн т годом ранее; за 10 месяцев было −16,4%. Это не доля, а именно падение тонн; и это порты Арктики (Мурманск, Архангельск, Сабетта и др.), а не только трасса СМП. Вопрос залу: кто видит этот спад в своих рейсах?</a:t>
             </a:r>
             <a:endParaRPr lang="en-US" dirty="0"/>
           </a:p>
@@ -2180,7 +2180,7 @@
           <a:p>
             <a:r>
               <a:rPr lang="en-US" dirty="0"/>
-              <a:t>[1:45] Это самый денежный слайд. Группировка растёт: зимой 2024 года работало восемь атомных ледоколов — исторический максимум; цель — 17 к 2030-му, 18 к 2035-му. Но ледоколы дорожают: смета двух ледоколов 22220 («Ленинград» и «Сталинград») выросла со 143 до 225,6 млрд рублей. Если закладывать это в тариф без внешнего финансирования, сутки проводки обойдутся примерно в 52 млн рублей; грузоотправители готовы платить около 15,7. Разрыв предлагают закрыть сбором — 20,07 рубля за тонну экспортного груза до конца 2036 года, платить будут 27 компаний; расчётный тариф со сбором — около 16 млн. Также обсуждают фиксированный тариф с 2028 года с индексацией. Важно: это проекты и публикации СМИ со ссылкой на документы, окончательное решение смотрите в первоисточниках. Интерактив №2: кто должен платить? Дайте 2 минуты на мнения: капитаны часто отвечают иначе, чем береговой офис.</a:t>
+              <a:t>[1:45] Это самый денежный слайд. Группировка растёт: зимой 2024 года работало восемь атомных ледоколов — исторический максимум; цель — 17 к 2030-му, 18 к 2035-му. Два новых ледокола проекта 22220 строит Балтийский завод: «Ленинград» (сдача декабрь 2028) и «Сталинград» (декабрь 2030). Они дорожают: по данным dp.ru «Ленинград» оценивался в 56,6 млрд, сейчас около 61,3; Балтзавод допускал рост цены до 30%. Как читать график. Все три столбца — суточный тариф проводки новыми ледоколами в млн рублей. Левый, 15,7, — максимум, который готовы платить грузоотправители. Средний, 16, — расчёт тарифа, если ввести сбор. Правый, 52, — расчёт, если ледоколы окупать только через тариф, без внешнего финансирования. Это цифры из публикаций Коммерсанта и The Insider по документам Минтранса; официально не принято, перед докладом перепроверьте. Сбор — 20,07 рубля за тонну экспортного груза до конца 2036 года, платить будут 27 компаний; предлагают также фиксированный тариф с 2028 года. Интерактив №2: кто должен платить? Капитаны и береговой офис часто отвечают по-разному.</a:t>
             </a:r>
             <a:endParaRPr lang="en-US" dirty="0"/>
           </a:p>
@@ -2356,7 +2356,7 @@
           <a:p>
             <a:r>
               <a:rPr lang="en-US" dirty="0"/>
-              <a:t>[1:30] Четыре замка, которые нельзя открыть в обход. Первый — судно: Polar Ship Certificate и PWOM, категория A, B или C по ледовой прочности. Второй — разрешение Администрации СМП. Третий — проводка, ледокольная и ледовая лоцманская. Четвёртый — экипаж: подготовка по Полярному кодексу, в STCW есть базовый уровень для вахтенных помощников и повышенный для капитанов и старших помощников. Экономия на любом из замков — это не экономия, а рассрочка по гораздо более дорогому платежу. Вопрос капитанам: какой из четырёх замков в реальной практике «скрипит» больше всего?</a:t>
+              <a:t>[1:30] Четыре замка, которые нельзя открыть в обход. Первый — судно: Polar Ship Certificate и PWOM. PWOM — Polar Water Operational Manual, руководство по эксплуатации судна в полярных водах: документ, который судовладелец готовит под конкретное судно и район плавания на основе оценки рисков, он входит в пакет для получения сертификата. Категории A, B, C — по ледовой прочности. Второй — разрешение Администрации СМП. Третий — проводка, ледокольная и ледовая лоцманская. Четвёртый — экипаж: подготовка по Полярному кодексу, в STCW есть базовый уровень для вахтенных помощников и повышенный для капитанов и старших помощников. Экономия на любом из замков — это не экономия, а рассрочка по гораздо более дорогому платежу. Вопрос капитанам: какой из четырёх замков в реальной практике «скрипит» больше всего?</a:t>
             </a:r>
             <a:endParaRPr lang="en-US" dirty="0"/>
           </a:p>
@@ -2444,7 +2444,7 @@
           <a:p>
             <a:r>
               <a:rPr lang="en-US" dirty="0"/>
-              <a:t>[1:30] Самое частое заблуждение: «льда стало меньше — стало проще». По данным NSIDC зимний максимум 2026 года, 14,29 млн кв. км, почти рекордно низкий. Но по Met Office сентябрь 2026 — 5,34 млн кв. км, 16-е место снизу, и это пятый по величине с 2007 года; лето было холодное и штормовое. Лёд меньше, но менее предсказуем, с торосами и дрейфом. Спасательный флот растёт: замминистра транспорта Пошивай на ВЭФ сказал, что в 2025–2026 принято пять ледовых спасательных судов, ещё пять буксиров планируют до конца 2027 года. 14 октября Северный флот учился спасать танкер в Карском море. Для нас вывод: рассчитывать на помощь поблизости пока нельзя, значит автономность и планирование — наша ответственность. Вопрос к залу: что для вас — стоп-сигнал?</a:t>
+              <a:t>[1:30] Самое частое заблуждение: «льда стало меньше — стало проще». По NSIDC зимний максимум 2026 года, 14,29 млн кв. км, почти рекордно низкий. Сентябрь 2026 по Met Office: среднее 5,34 млн кв. км — 16-й минимум за 48 лет спутниковых наблюдений (1979–2026), то есть льда много меньше, чем в 1980–2000-х, но пятый по величине с 2007 года; лето было холодное и штормовое. Лёд меньше, но менее предсказуем: торосы, дрейф. «5 + 5»: замминистра транспорта Пошивай на ВЭФ сообщил, что в 2025–2026 годах принято пять ледовых спасательных судов, а до конца 2027 года планируется принять ещё пять буксиров. Тезис про спасательный флот: он растёт, но речь о десятке единиц на акваторию в тысячи километров, и отраслевые материалы прямо говорят, что нужно больше аварийно-спасательных формирований. Поэтому помощь рядом не гарантирована, и автономность — наша ответственность. Рост флота — аргумент в пользу будущего, не в пользу сегодняшнего рейса. 14 октября Северный флот учился спасать танкер в Карском море. Вопрос залу: что для вас — стоп-сигнал?</a:t>
             </a:r>
             <a:endParaRPr lang="en-US" dirty="0"/>
           </a:p>
@@ -3405,8 +3405,8 @@
         </p:nvSpPr>
         <p:spPr>
           <a:xfrm>
-            <a:off x="548640" y="3017520"/>
-            <a:ext cx="5120640" cy="914400"/>
+            <a:off x="548640" y="2926080"/>
+            <a:ext cx="5120640" cy="731520"/>
           </a:xfrm>
           <a:prstGeom prst="rect">
             <a:avLst/>
@@ -3441,8 +3441,80 @@
         </p:nvSpPr>
         <p:spPr>
           <a:xfrm>
-            <a:off x="548640" y="4297680"/>
-            <a:ext cx="5943600" cy="320040"/>
+            <a:off x="548640" y="3703320"/>
+            <a:ext cx="5943600" cy="292608"/>
+          </a:xfrm>
+          <a:prstGeom prst="rect">
+            <a:avLst/>
+          </a:prstGeom>
+          <a:noFill/>
+          <a:ln/>
+        </p:spPr>
+        <p:txBody>
+          <a:bodyPr wrap="square" lIns="0" tIns="0" rIns="0" bIns="0" rtlCol="0" anchor="ctr"/>
+          <a:lstStyle/>
+          <a:p>
+            <a:pPr indent="0" marL="0">
+              <a:buNone/>
+            </a:pPr>
+            <a:r>
+              <a:rPr lang="en-US" sz="1800" b="1" dirty="0">
+                <a:solidFill>
+                  <a:schemeClr val="bg1"/>
+                </a:solidFill>
+              </a:rPr>
+              <a:t>Пицуков Михаил Георгиевич</a:t>
+            </a:r>
+            <a:endParaRPr lang="en-US" sz="1800" dirty="0"/>
+          </a:p>
+        </p:txBody>
+      </p:sp>
+      <p:sp>
+        <p:nvSpPr>
+          <p:cNvPr id="9" name="Text 7"/>
+          <p:cNvSpPr txBox="1"/>
+          <p:nvPr/>
+        </p:nvSpPr>
+        <p:spPr>
+          <a:xfrm>
+            <a:off x="548640" y="3995928"/>
+            <a:ext cx="5943600" cy="274320"/>
+          </a:xfrm>
+          <a:prstGeom prst="rect">
+            <a:avLst/>
+          </a:prstGeom>
+          <a:noFill/>
+          <a:ln/>
+        </p:spPr>
+        <p:txBody>
+          <a:bodyPr wrap="square" lIns="0" tIns="0" rIns="0" bIns="0" rtlCol="0" anchor="ctr"/>
+          <a:lstStyle/>
+          <a:p>
+            <a:pPr indent="0" marL="0">
+              <a:buNone/>
+            </a:pPr>
+            <a:r>
+              <a:rPr lang="en-US" sz="1400" dirty="0">
+                <a:solidFill>
+                  <a:schemeClr val="accent4"/>
+                </a:solidFill>
+              </a:rPr>
+              <a:t>менеджер департамента танкерных перевозок</a:t>
+            </a:r>
+            <a:endParaRPr lang="en-US" sz="1400" dirty="0"/>
+          </a:p>
+        </p:txBody>
+      </p:sp>
+      <p:sp>
+        <p:nvSpPr>
+          <p:cNvPr id="10" name="Text 8"/>
+          <p:cNvSpPr txBox="1"/>
+          <p:nvPr/>
+        </p:nvSpPr>
+        <p:spPr>
+          <a:xfrm>
+            <a:off x="548640" y="4526280"/>
+            <a:ext cx="5943600" cy="274320"/>
           </a:xfrm>
           <a:prstGeom prst="rect">
             <a:avLst/>
@@ -4761,7 +4833,7 @@
                   <a:schemeClr val="bg1"/>
                 </a:solidFill>
               </a:rPr>
-              <a:t>Плато около 37 млн т, ставка на 40+; основа — внутренние отгрузки, транзит менее 9%.</a:t>
+              <a:t>Плато около 37 млн т; Росатом прогнозирует 40+ млн т в 2026 г. Основа — внутренние отгрузки, транзит менее 9%.</a:t>
             </a:r>
             <a:endParaRPr lang="en-US" sz="1400" dirty="0"/>
           </a:p>
@@ -4858,7 +4930,7 @@
                   <a:schemeClr val="bg1"/>
                 </a:solidFill>
               </a:rPr>
-              <a:t>Проводка дорожает: сбор и тарифы решают экономику рейса, а сухие грузы пока слабое звено.</a:t>
+              <a:t>Проводка дорожает: проект ледосбора (20,07 ₽ за тонну экспортного груза) и новый тариф решат экономику рейса.</a:t>
             </a:r>
             <a:endParaRPr lang="en-US" sz="1400" dirty="0"/>
           </a:p>
@@ -5324,7 +5396,7 @@
                   <a:schemeClr val="tx1"/>
                 </a:solidFill>
               </a:rPr>
-              <a:t>Carnegie, NSIDC, Met Office, Reuters/LSEG, Meduza</a:t>
+              <a:t>Carnegie, CHNL, АСОП, NSIDC, Met Office, Reuters/LSEG</a:t>
             </a:r>
             <a:endParaRPr lang="en-US" sz="1400" dirty="0"/>
           </a:p>
@@ -5622,7 +5694,7 @@
                 <a:ea typeface="Cambria" pitchFamily="34" charset="-122"/>
                 <a:cs typeface="Cambria" pitchFamily="34" charset="-120"/>
               </a:rPr>
-              <a:t>Какая доля грузов на Севморпути — транзит между Азией и Европой?</a:t>
+              <a:t>Какая доля грузов на Севморпути — транзит (сквозной проход трассы)?</a:t>
             </a:r>
             <a:endParaRPr lang="en-US" sz="2400" dirty="0"/>
           </a:p>
@@ -6722,7 +6794,7 @@
                   <a:schemeClr val="tx1"/>
                 </a:solidFill>
               </a:rPr>
-              <a:t>транзит Азия–Европа, 103 прохода: менее 9% потока</a:t>
+              <a:t>сквозной транзит, 103 прохода в обе стороны: менее 9%</a:t>
             </a:r>
             <a:endParaRPr lang="en-US" sz="1400" dirty="0"/>
           </a:p>
@@ -6880,7 +6952,7 @@
                 <a:ea typeface="Cambria" pitchFamily="34" charset="-122"/>
                 <a:cs typeface="Cambria" pitchFamily="34" charset="-120"/>
               </a:rPr>
-              <a:t>−16,4%</a:t>
+              <a:t>−18,3%</a:t>
             </a:r>
             <a:endParaRPr lang="en-US" sz="3400" dirty="0"/>
           </a:p>
@@ -6916,7 +6988,7 @@
                   <a:schemeClr val="tx1"/>
                 </a:solidFill>
               </a:rPr>
-              <a:t>сухие грузы в портах Арктики, 10 мес. 2025</a:t>
+              <a:t>сухие грузы в портах Арктики: 21,3 млн т, 2025 к 2024</a:t>
             </a:r>
             <a:endParaRPr lang="en-US" sz="1400" dirty="0"/>
           </a:p>
@@ -7083,7 +7155,7 @@
                   <a:schemeClr val="accent3"/>
                 </a:solidFill>
               </a:rPr>
-              <a:t>Источники: Росатом (цифры 2025), Carnegie (103 прохода), Росморречфлот/АСОП по портам; Meduza, 2026 — сервис Sea Legend</a:t>
+              <a:t>Источники: Росатом; АСОП (порты); CHNL (состав 103 проходов, не официальные данные); Carnegie</a:t>
             </a:r>
             <a:endParaRPr lang="en-US" sz="1000" dirty="0"/>
           </a:p>
@@ -8006,8 +8078,8 @@
           <p:nvPr/>
         </p:nvGraphicFramePr>
         <p:xfrm>
-          <a:off x="457200" y="1188720"/>
-          <a:ext cx="4297680" cy="2651760"/>
+          <a:off x="457200" y="1143000"/>
+          <a:ext cx="4297680" cy="2103120"/>
         </p:xfrm>
         <a:graphic xmlns:a="http://schemas.openxmlformats.org/drawingml/2006/main">
           <a:graphicData uri="http://schemas.openxmlformats.org/drawingml/2006/chart">
@@ -8017,7 +8089,43 @@
       </p:graphicFrame>
       <p:sp>
         <p:nvSpPr>
-          <p:cNvPr id="4" name="Карточка"/>
+          <p:cNvPr id="4" name="Text 1"/>
+          <p:cNvSpPr txBox="1"/>
+          <p:nvPr/>
+        </p:nvSpPr>
+        <p:spPr>
+          <a:xfrm>
+            <a:off x="457200" y="3291840"/>
+            <a:ext cx="4297680" cy="640080"/>
+          </a:xfrm>
+          <a:prstGeom prst="rect">
+            <a:avLst/>
+          </a:prstGeom>
+          <a:noFill/>
+          <a:ln/>
+        </p:spPr>
+        <p:txBody>
+          <a:bodyPr wrap="square" lIns="0" tIns="0" rIns="0" bIns="0" rtlCol="0" anchor="t"/>
+          <a:lstStyle/>
+          <a:p>
+            <a:pPr indent="0" marL="0">
+              <a:buNone/>
+            </a:pPr>
+            <a:r>
+              <a:rPr lang="en-US" sz="1100" dirty="0">
+                <a:solidFill>
+                  <a:schemeClr val="accent3"/>
+                </a:solidFill>
+              </a:rPr>
+              <a:t>Слева: максимум, который готовы платить грузоотправители. В центре: расчёт тарифа при введении сбора. Справа: расчёт без внешнего финансирования.</a:t>
+            </a:r>
+            <a:endParaRPr lang="en-US" sz="1100" dirty="0"/>
+          </a:p>
+        </p:txBody>
+      </p:sp>
+      <p:sp>
+        <p:nvSpPr>
+          <p:cNvPr id="5" name="Карточка"/>
           <p:cNvSpPr/>
           <p:nvPr/>
         </p:nvSpPr>
@@ -8039,7 +8147,7 @@
       </p:sp>
       <p:sp>
         <p:nvSpPr>
-          <p:cNvPr id="5" name="Text 2"/>
+          <p:cNvPr id="6" name="Text 3"/>
           <p:cNvSpPr txBox="1"/>
           <p:nvPr/>
         </p:nvSpPr>
@@ -8089,7 +8197,7 @@
                   <a:schemeClr val="tx1"/>
                 </a:solidFill>
               </a:rPr>
-              <a:t>Два ледокола 22220: смета выросла со 143 до 225,6 млрд ₽</a:t>
+              <a:t>«Ленинград» (сдача 12.2028) и «Сталинград» (12.2030), проект 22220: стоимость растёт</a:t>
             </a:r>
             <a:endParaRPr lang="en-US" sz="1400" dirty="0"/>
           </a:p>
@@ -8107,7 +8215,7 @@
                   <a:schemeClr val="tx1"/>
                 </a:solidFill>
               </a:rPr>
-              <a:t>Проект сбора: 20,07 ₽ за тонну экспортного груза, до 2036 г., платят 27 компаний</a:t>
+              <a:t>Проект сбора на их достройку: 20,07 ₽ за тонну экспортного груза до 2036 г., 27 компаний</a:t>
             </a:r>
             <a:endParaRPr lang="en-US" sz="1400" dirty="0"/>
           </a:p>
@@ -8133,7 +8241,7 @@
       </p:sp>
       <p:sp>
         <p:nvSpPr>
-          <p:cNvPr id="6" name="Вопрос залу"/>
+          <p:cNvPr id="7" name="Вопрос залу"/>
           <p:cNvSpPr/>
           <p:nvPr/>
         </p:nvSpPr>
@@ -8155,7 +8263,7 @@
       </p:sp>
       <p:sp>
         <p:nvSpPr>
-          <p:cNvPr id="7" name="Text 4"/>
+          <p:cNvPr id="8" name="Text 5"/>
           <p:cNvSpPr txBox="1"/>
           <p:nvPr/>
         </p:nvSpPr>
@@ -8202,7 +8310,7 @@
       </p:sp>
       <p:sp>
         <p:nvSpPr>
-          <p:cNvPr id="8" name="Источник"/>
+          <p:cNvPr id="9" name="Источник"/>
           <p:cNvSpPr txBox="1"/>
           <p:nvPr/>
         </p:nvSpPr>
@@ -8230,7 +8338,7 @@
                   <a:schemeClr val="accent3"/>
                 </a:solidFill>
               </a:rPr>
-              <a:t>Источники: проект Минтранса и документы Росатома по публикациям Коммерсантъ и The Insider (проект, не документ в силе)</a:t>
+              <a:t>Источники: Коммерсантъ, The Insider (проект Минтранса, не документ в силе), dp.ru, Балтийский завод</a:t>
             </a:r>
             <a:endParaRPr lang="en-US" sz="1000" dirty="0"/>
           </a:p>
@@ -8998,7 +9106,7 @@
                   <a:schemeClr val="tx1"/>
                 </a:solidFill>
               </a:rPr>
-              <a:t>Polar Ship Certificate и PWOM; категории A, B, C по ледовой прочности</a:t>
+              <a:t>Polar Ship Certificate и PWOM (руководство по эксплуатации судна в полярных водах); категории A, B, C</a:t>
             </a:r>
             <a:endParaRPr lang="en-US" sz="1300" dirty="0"/>
           </a:p>
@@ -9855,7 +9963,7 @@
                   <a:schemeClr val="tx1"/>
                 </a:solidFill>
               </a:rPr>
-              <a:t>млн км²: максимум 15.03.2026, почти рекордный минимум</a:t>
+              <a:t>млн км²: зимний максимум 15.03.2026, почти рекордно низкий</a:t>
             </a:r>
             <a:endParaRPr lang="en-US" sz="1400" dirty="0"/>
           </a:p>
@@ -9952,7 +10060,7 @@
                   <a:schemeClr val="tx1"/>
                 </a:solidFill>
               </a:rPr>
-              <a:t>млн км²: сентябрь 2026, 16-е место снизу</a:t>
+              <a:t>млн км²: среднее за сентябрь 2026; 16-й минимум из 48 лет (1979–2026)</a:t>
             </a:r>
             <a:endParaRPr lang="en-US" sz="1400" dirty="0"/>
           </a:p>
@@ -10049,7 +10157,7 @@
                   <a:schemeClr val="tx1"/>
                 </a:solidFill>
               </a:rPr>
-              <a:t>спасательных судов принято в 2025–26 и буксиров до 2027</a:t>
+              <a:t>5 спасательных судов принято в 2025–26 и 5 буксиров до конца 2027</a:t>
             </a:r>
             <a:endParaRPr lang="en-US" sz="1400" dirty="0"/>
           </a:p>
@@ -10147,7 +10255,7 @@
                   <a:schemeClr val="tx1"/>
                 </a:solidFill>
               </a:rPr>
-              <a:t>Спасательный флот только растёт: полагаться нужно на собственную готовность.</a:t>
+              <a:t>Спасательный флот растёт, но для огромной акватории его пока мало: помощь может быть далеко, нужна автономность.</a:t>
             </a:r>
             <a:endParaRPr lang="en-US" sz="1400" dirty="0"/>
           </a:p>

</xml_diff>

<commit_message>
Add speaker vCard QR code to first and last slides; update title wording
Co-Authored-By: Claude Sonnet 5.5 <noreply@anthropic.com>
Claude-Session: https://claude.ai/code/session_01NknPrkgT7ASbMFec99CZjD
</commit_message>
<xml_diff>
--- a/Arktika_dengi_i_bezopasnost.pptx
+++ b/Arktika_dengi_i_bezopasnost.pptx
@@ -119,38 +119,38 @@
   <p:extLst>
     <p:ext uri="{521415D9-36F7-43E2-AB2F-B90AF26B5E84}">
       <p14:sectionLst xmlns:p14="http://schemas.microsoft.com/office/powerpoint/2010/main">
-        <p14:section name="Вступление" id="{27dc4dba-08fe-01ae-620d-448acccc284a}">
+        <p14:section name="Вступление" id="{dc978d54-fa8d-e593-7517-99450629be92}">
           <p14:sldIdLst>
             <p14:sldId id="256"/>
             <p14:sldId id="257"/>
           </p14:sldIdLst>
         </p14:section>
-        <p14:section name="Картина" id="{705d2267-4eda-a37f-cf4a-3c8be903f442}">
+        <p14:section name="Картина" id="{36d72c7b-10f4-b583-fa40-9c5c683a7d4c}">
           <p14:sldIdLst>
             <p14:sldId id="258"/>
             <p14:sldId id="259"/>
           </p14:sldIdLst>
         </p14:section>
-        <p14:section name="Деньги" id="{9da74fce-2bcb-7066-13bd-4f78d6d7c1ee}">
+        <p14:section name="Деньги" id="{14bd378a-5d6c-95a2-ce4f-d81538f3e3aa}">
           <p14:sldIdLst>
             <p14:sldId id="260"/>
             <p14:sldId id="261"/>
             <p14:sldId id="262"/>
           </p14:sldIdLst>
         </p14:section>
-        <p14:section name="Безопасность" id="{7a259277-c8f0-8cdc-895f-668ccb69fb15}">
+        <p14:section name="Безопасность" id="{374a7da9-9b55-2ff0-8b46-a0e3c7ecb387}">
           <p14:sldIdLst>
             <p14:sldId id="263"/>
             <p14:sldId id="264"/>
           </p14:sldIdLst>
         </p14:section>
-        <p14:section name="Риски" id="{4b984e1f-d846-65ec-af76-9824f52396ec}">
+        <p14:section name="Риски" id="{985db7f7-adaf-f5f4-7906-d7c3f76ec1b5}">
           <p14:sldIdLst>
             <p14:sldId id="265"/>
             <p14:sldId id="266"/>
           </p14:sldIdLst>
         </p14:section>
-        <p14:section name="Итоги" id="{8c3887d8-8e41-70e6-cc7a-78cc5e72f488}">
+        <p14:section name="Итоги" id="{db252649-a13f-2cae-9da6-318248849e0d}">
           <p14:sldIdLst>
             <p14:sldId id="267"/>
             <p14:sldId id="268"/>
@@ -1388,7 +1388,7 @@
           <a:p>
             <a:r>
               <a:rPr lang="en-US" dirty="0"/>
-              <a:t>[0:30] Добрый день, коллеги. Меня зовут Михаил Георгиевич Пицуков, я менеджер департамента танкерных перевозок. Тема — Арктика через призму двух вещей, которые в нашей профессии вечно спорят: деньги и безопасность. Формат: 15 минут рассказа, по ходу несколько вопросов к залу — отвечайте с места, мне важнее ваш опыт, чем мой слайд. Потом 15 минут обсуждения. Данные — на октябрь 2026, по официальным источникам: Росатом, Минтранс, Минвостокразвития, Правительство, плюс международные для сверки. Где источники расходятся — скажу прямо.</a:t>
+              <a:t>[0:30] Добрый день, коллеги. Меня зовут Михаил Георгиевич Пицуков, я менеджер отдела танкерных перевозок. Мои контакты — по QR-коду на этом и на последнем слайде. Тема — Арктика через призму двух вещей, которые в нашей профессии вечно спорят: деньги и безопасность. Формат: 15 минут рассказа, по ходу несколько вопросов к залу — отвечайте с места, мне важнее ваш опыт, чем мой слайд. Потом 15 минут обсуждения. Данные — на октябрь 2026, по официальным источникам: Росатом, Минтранс, Минвостокразвития, Правительство, плюс международные для сверки. Где источники расходятся — скажу прямо.</a:t>
             </a:r>
             <a:endParaRPr lang="en-US" dirty="0"/>
           </a:p>
@@ -3499,7 +3499,7 @@
                   <a:schemeClr val="accent4"/>
                 </a:solidFill>
               </a:rPr>
-              <a:t>менеджер департамента танкерных перевозок</a:t>
+              <a:t>менеджер отдела танкерных перевозок</a:t>
             </a:r>
             <a:endParaRPr lang="en-US" sz="1400" dirty="0"/>
           </a:p>
@@ -3507,7 +3507,89 @@
       </p:sp>
       <p:sp>
         <p:nvSpPr>
-          <p:cNvPr id="10" name="Text 8"/>
+          <p:cNvPr id="10" name="QR фон"/>
+          <p:cNvSpPr/>
+          <p:nvPr/>
+        </p:nvSpPr>
+        <p:spPr>
+          <a:xfrm>
+            <a:off x="7315200" y="3246120"/>
+            <a:ext cx="1371600" cy="1508760"/>
+          </a:xfrm>
+          <a:prstGeom prst="roundRect">
+            <a:avLst>
+              <a:gd name="adj" fmla="val 5333"/>
+            </a:avLst>
+          </a:prstGeom>
+          <a:solidFill>
+            <a:srgbClr val="FFFFFF"/>
+          </a:solidFill>
+          <a:ln/>
+        </p:spPr>
+      </p:sp>
+      <p:pic>
+        <p:nvPicPr>
+          <p:cNvPr id="11" name="Image 0" descr="QR-код с контактами докладчика">    </p:cNvPr>
+          <p:cNvPicPr>
+            <a:picLocks noChangeAspect="1"/>
+          </p:cNvPicPr>
+          <p:nvPr/>
+        </p:nvPicPr>
+        <p:blipFill>
+          <a:blip r:embed="rId1"/>
+          <a:stretch>
+            <a:fillRect/>
+          </a:stretch>
+        </p:blipFill>
+        <p:spPr>
+          <a:xfrm>
+            <a:off x="7406640" y="3310128"/>
+            <a:ext cx="1188720" cy="1188720"/>
+          </a:xfrm>
+          <a:prstGeom prst="rect">
+            <a:avLst/>
+          </a:prstGeom>
+        </p:spPr>
+      </p:pic>
+      <p:sp>
+        <p:nvSpPr>
+          <p:cNvPr id="12" name="Text 9"/>
+          <p:cNvSpPr txBox="1"/>
+          <p:nvPr/>
+        </p:nvSpPr>
+        <p:spPr>
+          <a:xfrm>
+            <a:off x="7315200" y="4517136"/>
+            <a:ext cx="1371600" cy="201168"/>
+          </a:xfrm>
+          <a:prstGeom prst="rect">
+            <a:avLst/>
+          </a:prstGeom>
+          <a:noFill/>
+          <a:ln/>
+        </p:spPr>
+        <p:txBody>
+          <a:bodyPr wrap="square" lIns="0" tIns="0" rIns="0" bIns="0" rtlCol="0" anchor="ctr"/>
+          <a:lstStyle/>
+          <a:p>
+            <a:pPr algn="ctr" indent="0" marL="0">
+              <a:buNone/>
+            </a:pPr>
+            <a:r>
+              <a:rPr lang="en-US" sz="1100" b="1" dirty="0">
+                <a:solidFill>
+                  <a:schemeClr val="tx1"/>
+                </a:solidFill>
+              </a:rPr>
+              <a:t>Контакты</a:t>
+            </a:r>
+            <a:endParaRPr lang="en-US" sz="1100" dirty="0"/>
+          </a:p>
+        </p:txBody>
+      </p:sp>
+      <p:sp>
+        <p:nvSpPr>
+          <p:cNvPr id="13" name="Text 10"/>
           <p:cNvSpPr txBox="1"/>
           <p:nvPr/>
         </p:nvSpPr>
@@ -3535,7 +3617,7 @@
                   <a:schemeClr val="bg2"/>
                 </a:solidFill>
               </a:rPr>
-              <a:t>Северный проект  ·  Доклад для капитанов и берегового офиса  ·  октябрь 2026</a:t>
+              <a:t>ООО «ТК Северный Проект»  ·  Доклад для капитанов и берегового офиса  ·  октябрь 2026</a:t>
             </a:r>
             <a:endParaRPr lang="en-US" sz="1200" dirty="0"/>
           </a:p>
@@ -5035,7 +5117,89 @@
       </p:sp>
       <p:sp>
         <p:nvSpPr>
-          <p:cNvPr id="12" name="Text 10"/>
+          <p:cNvPr id="12" name="QR фон"/>
+          <p:cNvSpPr/>
+          <p:nvPr/>
+        </p:nvSpPr>
+        <p:spPr>
+          <a:xfrm>
+            <a:off x="7315200" y="3246120"/>
+            <a:ext cx="1371600" cy="1508760"/>
+          </a:xfrm>
+          <a:prstGeom prst="roundRect">
+            <a:avLst>
+              <a:gd name="adj" fmla="val 5333"/>
+            </a:avLst>
+          </a:prstGeom>
+          <a:solidFill>
+            <a:srgbClr val="FFFFFF"/>
+          </a:solidFill>
+          <a:ln/>
+        </p:spPr>
+      </p:sp>
+      <p:pic>
+        <p:nvPicPr>
+          <p:cNvPr id="13" name="Image 0" descr="QR-код с контактами докладчика">    </p:cNvPr>
+          <p:cNvPicPr>
+            <a:picLocks noChangeAspect="1"/>
+          </p:cNvPicPr>
+          <p:nvPr/>
+        </p:nvPicPr>
+        <p:blipFill>
+          <a:blip r:embed="rId1"/>
+          <a:stretch>
+            <a:fillRect/>
+          </a:stretch>
+        </p:blipFill>
+        <p:spPr>
+          <a:xfrm>
+            <a:off x="7406640" y="3310128"/>
+            <a:ext cx="1188720" cy="1188720"/>
+          </a:xfrm>
+          <a:prstGeom prst="rect">
+            <a:avLst/>
+          </a:prstGeom>
+        </p:spPr>
+      </p:pic>
+      <p:sp>
+        <p:nvSpPr>
+          <p:cNvPr id="14" name="Text 11"/>
+          <p:cNvSpPr txBox="1"/>
+          <p:nvPr/>
+        </p:nvSpPr>
+        <p:spPr>
+          <a:xfrm>
+            <a:off x="7315200" y="4517136"/>
+            <a:ext cx="1371600" cy="201168"/>
+          </a:xfrm>
+          <a:prstGeom prst="rect">
+            <a:avLst/>
+          </a:prstGeom>
+          <a:noFill/>
+          <a:ln/>
+        </p:spPr>
+        <p:txBody>
+          <a:bodyPr wrap="square" lIns="0" tIns="0" rIns="0" bIns="0" rtlCol="0" anchor="ctr"/>
+          <a:lstStyle/>
+          <a:p>
+            <a:pPr algn="ctr" indent="0" marL="0">
+              <a:buNone/>
+            </a:pPr>
+            <a:r>
+              <a:rPr lang="en-US" sz="1100" b="1" dirty="0">
+                <a:solidFill>
+                  <a:schemeClr val="tx1"/>
+                </a:solidFill>
+              </a:rPr>
+              <a:t>Контакты</a:t>
+            </a:r>
+            <a:endParaRPr lang="en-US" sz="1100" dirty="0"/>
+          </a:p>
+        </p:txBody>
+      </p:sp>
+      <p:sp>
+        <p:nvSpPr>
+          <p:cNvPr id="15" name="Text 12"/>
           <p:cNvSpPr txBox="1"/>
           <p:nvPr/>
         </p:nvSpPr>
@@ -5074,14 +5238,14 @@
       </p:sp>
       <p:sp>
         <p:nvSpPr>
-          <p:cNvPr id="13" name="Text 11"/>
+          <p:cNvPr id="16" name="Text 13"/>
           <p:cNvSpPr txBox="1"/>
           <p:nvPr/>
         </p:nvSpPr>
         <p:spPr>
           <a:xfrm>
             <a:off x="457200" y="3657600"/>
-            <a:ext cx="8229600" cy="1005840"/>
+            <a:ext cx="6675120" cy="1005840"/>
           </a:xfrm>
           <a:prstGeom prst="rect">
             <a:avLst/>

</xml_diff>

<commit_message>
Add work email to speaker vCard QR code
Co-Authored-By: Claude Sonnet 5.5 <noreply@anthropic.com>
Claude-Session: https://claude.ai/code/session_01NknPrkgT7ASbMFec99CZjD
</commit_message>
<xml_diff>
--- a/Arktika_dengi_i_bezopasnost.pptx
+++ b/Arktika_dengi_i_bezopasnost.pptx
@@ -119,38 +119,38 @@
   <p:extLst>
     <p:ext uri="{521415D9-36F7-43E2-AB2F-B90AF26B5E84}">
       <p14:sectionLst xmlns:p14="http://schemas.microsoft.com/office/powerpoint/2010/main">
-        <p14:section name="Вступление" id="{dc978d54-fa8d-e593-7517-99450629be92}">
+        <p14:section name="Вступление" id="{c11ce658-e9d7-b4c5-876e-4a9fdbda2a97}">
           <p14:sldIdLst>
             <p14:sldId id="256"/>
             <p14:sldId id="257"/>
           </p14:sldIdLst>
         </p14:section>
-        <p14:section name="Картина" id="{36d72c7b-10f4-b583-fa40-9c5c683a7d4c}">
+        <p14:section name="Картина" id="{ddc4fc1d-3238-a154-c5ed-ae4e90b47e30}">
           <p14:sldIdLst>
             <p14:sldId id="258"/>
             <p14:sldId id="259"/>
           </p14:sldIdLst>
         </p14:section>
-        <p14:section name="Деньги" id="{14bd378a-5d6c-95a2-ce4f-d81538f3e3aa}">
+        <p14:section name="Деньги" id="{c6efb48b-c4e2-2168-db9f-7e3223d881ab}">
           <p14:sldIdLst>
             <p14:sldId id="260"/>
             <p14:sldId id="261"/>
             <p14:sldId id="262"/>
           </p14:sldIdLst>
         </p14:section>
-        <p14:section name="Безопасность" id="{374a7da9-9b55-2ff0-8b46-a0e3c7ecb387}">
+        <p14:section name="Безопасность" id="{5f11ebf3-e084-ea82-0823-4369a470ce31}">
           <p14:sldIdLst>
             <p14:sldId id="263"/>
             <p14:sldId id="264"/>
           </p14:sldIdLst>
         </p14:section>
-        <p14:section name="Риски" id="{985db7f7-adaf-f5f4-7906-d7c3f76ec1b5}">
+        <p14:section name="Риски" id="{3c23471a-1b17-ffc7-6d4e-a0598329d1fe}">
           <p14:sldIdLst>
             <p14:sldId id="265"/>
             <p14:sldId id="266"/>
           </p14:sldIdLst>
         </p14:section>
-        <p14:section name="Итоги" id="{db252649-a13f-2cae-9da6-318248849e0d}">
+        <p14:section name="Итоги" id="{55f7705d-83c2-cf07-0b46-f4fb130118dd}">
           <p14:sldIdLst>
             <p14:sldId id="267"/>
             <p14:sldId id="268"/>

</xml_diff>